<commit_message>
Deck v2: live product screenshots, QR code for live URL, walkthrough slide
</commit_message>
<xml_diff>
--- a/BloodBridge_Pitch.pptx
+++ b/BloodBridge_Pitch.pptx
@@ -11,6 +11,7 @@
     <p:sldId id="259" r:id="rId10"/>
     <p:sldId id="260" r:id="rId11"/>
     <p:sldId id="261" r:id="rId12"/>
+    <p:sldId id="262" r:id="rId13"/>
   </p:sldIdLst>
   <p:sldSz cx="12191695" cy="6858000" type="screen4x3"/>
   <p:notesSz cx="6858000" cy="9144000"/>
@@ -3197,7 +3198,7 @@
         </p:blipFill>
         <p:spPr>
           <a:xfrm>
-            <a:off x="5458968" y="658368"/>
+            <a:off x="5458968" y="1527048"/>
             <a:ext cx="1280160" cy="1280160"/>
           </a:xfrm>
           <a:prstGeom prst="rect">
@@ -3213,7 +3214,7 @@
         </p:nvSpPr>
         <p:spPr>
           <a:xfrm>
-            <a:off x="914400" y="1993392"/>
+            <a:off x="914400" y="2862072"/>
             <a:ext cx="10360152" cy="914400"/>
           </a:xfrm>
           <a:prstGeom prst="rect">
@@ -3252,7 +3253,7 @@
         </p:nvSpPr>
         <p:spPr>
           <a:xfrm>
-            <a:off x="914400" y="2907792"/>
+            <a:off x="914400" y="3776472"/>
             <a:ext cx="10360152" cy="457200"/>
           </a:xfrm>
           <a:prstGeom prst="rect">
@@ -3291,7 +3292,7 @@
         </p:nvSpPr>
         <p:spPr>
           <a:xfrm>
-            <a:off x="914400" y="3456432"/>
+            <a:off x="914400" y="4325112"/>
             <a:ext cx="10360152" cy="457200"/>
           </a:xfrm>
           <a:prstGeom prst="rect">
@@ -3330,20 +3331,18 @@
         </p:nvSpPr>
         <p:spPr>
           <a:xfrm>
-            <a:off x="764895" y="4224528"/>
-            <a:ext cx="2487168" cy="475488"/>
+            <a:off x="4087368" y="4956048"/>
+            <a:ext cx="4023360" cy="402336"/>
           </a:xfrm>
           <a:prstGeom prst="roundRect">
-            <a:avLst>
-              <a:gd name="adj" fmla="val 50000"/>
-            </a:avLst>
+            <a:avLst/>
           </a:prstGeom>
           <a:solidFill>
-            <a:srgbClr val="FFFFFF"/>
+            <a:srgbClr val="ECFCF3"/>
           </a:solidFill>
           <a:ln w="15875">
             <a:solidFill>
-              <a:srgbClr val="E7E5E4"/>
+              <a:srgbClr val="15803D"/>
             </a:solidFill>
           </a:ln>
           <a:effectLst/>
@@ -3374,201 +3373,18 @@
             <a:r>
               <a:rPr sz="1200" b="1">
                 <a:solidFill>
-                  <a:srgbClr val="1C1917"/>
-                </a:solidFill>
-                <a:latin typeface="Calibri"/>
-              </a:rPr>
-              <a:t>Working full-stack MVP</a:t>
-            </a:r>
-          </a:p>
-        </p:txBody>
-      </p:sp>
-      <p:sp>
-        <p:nvSpPr>
-          <p:cNvPr id="9" name="Rounded Rectangle 8"/>
-          <p:cNvSpPr/>
-          <p:nvPr/>
-        </p:nvSpPr>
-        <p:spPr>
-          <a:xfrm>
-            <a:off x="3489807" y="4224528"/>
-            <a:ext cx="2487168" cy="475488"/>
-          </a:xfrm>
-          <a:prstGeom prst="roundRect">
-            <a:avLst>
-              <a:gd name="adj" fmla="val 50000"/>
-            </a:avLst>
-          </a:prstGeom>
-          <a:solidFill>
-            <a:srgbClr val="FFFFFF"/>
-          </a:solidFill>
-          <a:ln w="15875">
-            <a:solidFill>
-              <a:srgbClr val="E7E5E4"/>
-            </a:solidFill>
-          </a:ln>
-          <a:effectLst/>
-        </p:spPr>
-        <p:style>
-          <a:lnRef idx="1">
-            <a:schemeClr val="accent1"/>
-          </a:lnRef>
-          <a:fillRef idx="3">
-            <a:schemeClr val="accent1"/>
-          </a:fillRef>
-          <a:effectRef idx="2">
-            <a:schemeClr val="accent1"/>
-          </a:effectRef>
-          <a:fontRef idx="minor">
-            <a:schemeClr val="lt1"/>
-          </a:fontRef>
-        </p:style>
-        <p:txBody>
-          <a:bodyPr rtlCol="0" anchor="ctr" wrap="square" lIns="54864" rIns="54864" tIns="36576" bIns="36576"/>
-          <a:lstStyle/>
-          <a:p>
-            <a:pPr algn="ctr">
-              <a:spcAft>
-                <a:spcPts val="0"/>
-              </a:spcAft>
-            </a:pPr>
-            <a:r>
-              <a:rPr sz="1200" b="1">
-                <a:solidFill>
-                  <a:srgbClr val="1C1917"/>
-                </a:solidFill>
-                <a:latin typeface="Calibri"/>
-              </a:rPr>
-              <a:t>63 backend tests</a:t>
-            </a:r>
-          </a:p>
-        </p:txBody>
-      </p:sp>
-      <p:sp>
-        <p:nvSpPr>
-          <p:cNvPr id="10" name="Rounded Rectangle 9"/>
-          <p:cNvSpPr/>
-          <p:nvPr/>
-        </p:nvSpPr>
-        <p:spPr>
-          <a:xfrm>
-            <a:off x="6214719" y="4224528"/>
-            <a:ext cx="2487168" cy="475488"/>
-          </a:xfrm>
-          <a:prstGeom prst="roundRect">
-            <a:avLst>
-              <a:gd name="adj" fmla="val 50000"/>
-            </a:avLst>
-          </a:prstGeom>
-          <a:solidFill>
-            <a:srgbClr val="FFFFFF"/>
-          </a:solidFill>
-          <a:ln w="15875">
-            <a:solidFill>
-              <a:srgbClr val="E7E5E4"/>
-            </a:solidFill>
-          </a:ln>
-          <a:effectLst/>
-        </p:spPr>
-        <p:style>
-          <a:lnRef idx="1">
-            <a:schemeClr val="accent1"/>
-          </a:lnRef>
-          <a:fillRef idx="3">
-            <a:schemeClr val="accent1"/>
-          </a:fillRef>
-          <a:effectRef idx="2">
-            <a:schemeClr val="accent1"/>
-          </a:effectRef>
-          <a:fontRef idx="minor">
-            <a:schemeClr val="lt1"/>
-          </a:fontRef>
-        </p:style>
-        <p:txBody>
-          <a:bodyPr rtlCol="0" anchor="ctr" wrap="square" lIns="54864" rIns="54864" tIns="36576" bIns="36576"/>
-          <a:lstStyle/>
-          <a:p>
-            <a:pPr algn="ctr">
-              <a:spcAft>
-                <a:spcPts val="0"/>
-              </a:spcAft>
-            </a:pPr>
-            <a:r>
-              <a:rPr sz="1200" b="1">
-                <a:solidFill>
-                  <a:srgbClr val="1C1917"/>
-                </a:solidFill>
-                <a:latin typeface="Calibri"/>
-              </a:rPr>
-              <a:t>Privacy-first design</a:t>
-            </a:r>
-          </a:p>
-        </p:txBody>
-      </p:sp>
-      <p:sp>
-        <p:nvSpPr>
-          <p:cNvPr id="11" name="Rounded Rectangle 10"/>
-          <p:cNvSpPr/>
-          <p:nvPr/>
-        </p:nvSpPr>
-        <p:spPr>
-          <a:xfrm>
-            <a:off x="8939631" y="4224528"/>
-            <a:ext cx="2487168" cy="475488"/>
-          </a:xfrm>
-          <a:prstGeom prst="roundRect">
-            <a:avLst>
-              <a:gd name="adj" fmla="val 50000"/>
-            </a:avLst>
-          </a:prstGeom>
-          <a:solidFill>
-            <a:srgbClr val="FFFFFF"/>
-          </a:solidFill>
-          <a:ln w="15875">
-            <a:solidFill>
-              <a:srgbClr val="E7E5E4"/>
-            </a:solidFill>
-          </a:ln>
-          <a:effectLst/>
-        </p:spPr>
-        <p:style>
-          <a:lnRef idx="1">
-            <a:schemeClr val="accent1"/>
-          </a:lnRef>
-          <a:fillRef idx="3">
-            <a:schemeClr val="accent1"/>
-          </a:fillRef>
-          <a:effectRef idx="2">
-            <a:schemeClr val="accent1"/>
-          </a:effectRef>
-          <a:fontRef idx="minor">
-            <a:schemeClr val="lt1"/>
-          </a:fontRef>
-        </p:style>
-        <p:txBody>
-          <a:bodyPr rtlCol="0" anchor="ctr" wrap="square" lIns="54864" rIns="54864" tIns="36576" bIns="36576"/>
-          <a:lstStyle/>
-          <a:p>
-            <a:pPr algn="ctr">
-              <a:spcAft>
-                <a:spcPts val="0"/>
-              </a:spcAft>
-            </a:pPr>
-            <a:r>
-              <a:rPr sz="1200" b="1">
-                <a:solidFill>
-                  <a:srgbClr val="1C1917"/>
-                </a:solidFill>
-                <a:latin typeface="Calibri"/>
-              </a:rPr>
-              <a:t>WhatsApp-ready engine</a:t>
-            </a:r>
-          </a:p>
-        </p:txBody>
-      </p:sp>
-      <p:sp>
-        <p:nvSpPr>
-          <p:cNvPr id="12" name="Rectangle 11"/>
+                  <a:srgbClr val="15803D"/>
+                </a:solidFill>
+                <a:latin typeface="Calibri"/>
+              </a:rPr>
+              <a:t>●  LIVE NOW  -  it works in production</a:t>
+            </a:r>
+          </a:p>
+        </p:txBody>
+      </p:sp>
+      <p:sp>
+        <p:nvSpPr>
+          <p:cNvPr id="9" name="Rectangle 8"/>
           <p:cNvSpPr/>
           <p:nvPr/>
         </p:nvSpPr>
@@ -3797,7 +3613,7 @@
                 </a:solidFill>
                 <a:latin typeface="Calibri"/>
               </a:rPr>
-              <a:t>BloodBridge - AI-assisted blood donor discovery</a:t>
+              <a:t>BloodBridge - AI-assisted blood donor discovery  ·  LIVE: https://bloodbridge-app.riteshnethi-art.workers.dev</a:t>
             </a:r>
           </a:p>
         </p:txBody>
@@ -3810,8 +3626,8 @@
         </p:nvSpPr>
         <p:spPr>
           <a:xfrm>
-            <a:off x="11247120" y="6473952"/>
-            <a:ext cx="548640" cy="274320"/>
+            <a:off x="10972800" y="6473952"/>
+            <a:ext cx="822960" cy="274320"/>
           </a:xfrm>
           <a:prstGeom prst="rect">
             <a:avLst/>
@@ -3836,7 +3652,7 @@
                 </a:solidFill>
                 <a:latin typeface="Calibri"/>
               </a:rPr>
-              <a:t>2 / 6</a:t>
+              <a:t>2 / 7</a:t>
             </a:r>
           </a:p>
         </p:txBody>
@@ -4570,7 +4386,7 @@
                 </a:solidFill>
                 <a:latin typeface="Calibri"/>
               </a:rPr>
-              <a:t>BloodBridge - AI-assisted blood donor discovery</a:t>
+              <a:t>BloodBridge - AI-assisted blood donor discovery  ·  LIVE: https://bloodbridge-app.riteshnethi-art.workers.dev</a:t>
             </a:r>
           </a:p>
         </p:txBody>
@@ -4583,8 +4399,8 @@
         </p:nvSpPr>
         <p:spPr>
           <a:xfrm>
-            <a:off x="11247120" y="6473952"/>
-            <a:ext cx="548640" cy="274320"/>
+            <a:off x="10972800" y="6473952"/>
+            <a:ext cx="822960" cy="274320"/>
           </a:xfrm>
           <a:prstGeom prst="rect">
             <a:avLst/>
@@ -4609,7 +4425,7 @@
                 </a:solidFill>
                 <a:latin typeface="Calibri"/>
               </a:rPr>
-              <a:t>3 / 6</a:t>
+              <a:t>3 / 7</a:t>
             </a:r>
           </a:p>
         </p:txBody>
@@ -5554,7 +5370,7 @@
                 </a:solidFill>
                 <a:latin typeface="Calibri"/>
               </a:rPr>
-              <a:t>63</a:t>
+              <a:t>8</a:t>
             </a:r>
             <a:r>
               <a:rPr sz="1150" b="1">
@@ -5563,7 +5379,7 @@
                 </a:solidFill>
                 <a:latin typeface="Calibri"/>
               </a:rPr>
-              <a:t>   backend pytest tests</a:t>
+              <a:t>   blood groups covered</a:t>
             </a:r>
           </a:p>
           <a:p>
@@ -5579,7 +5395,7 @@
                 </a:solidFill>
                 <a:latin typeface="Calibri"/>
               </a:rPr>
-              <a:t>compatibility, matching, referrals, assistant</a:t>
+              <a:t>full who-can-give-whom compatibility matrix</a:t>
             </a:r>
           </a:p>
         </p:txBody>
@@ -5638,7 +5454,7 @@
                 </a:solidFill>
                 <a:latin typeface="Calibri"/>
               </a:rPr>
-              <a:t>10</a:t>
+              <a:t>&lt;1 min</a:t>
             </a:r>
             <a:r>
               <a:rPr sz="1150" b="1">
@@ -5647,7 +5463,7 @@
                 </a:solidFill>
                 <a:latin typeface="Calibri"/>
               </a:rPr>
-              <a:t>   frontend vitest tests</a:t>
+              <a:t>   from plea to ranked list</a:t>
             </a:r>
           </a:p>
           <a:p>
@@ -5663,7 +5479,7 @@
                 </a:solidFill>
                 <a:latin typeface="Calibri"/>
               </a:rPr>
-              <a:t>forms, validation, routing</a:t>
+              <a:t>one free-text message in, ranked donors out</a:t>
             </a:r>
           </a:p>
         </p:txBody>
@@ -5731,7 +5547,7 @@
                 </a:solidFill>
                 <a:latin typeface="Calibri"/>
               </a:rPr>
-              <a:t>   console errors</a:t>
+              <a:t>   donor numbers exposed</a:t>
             </a:r>
           </a:p>
           <a:p>
@@ -5747,7 +5563,7 @@
                 </a:solidFill>
                 <a:latin typeface="Calibri"/>
               </a:rPr>
-              <a:t>in the live end-to-end browser run</a:t>
+              <a:t>contact opens only after a donor accepts</a:t>
             </a:r>
           </a:p>
         </p:txBody>
@@ -5926,7 +5742,7 @@
                 </a:solidFill>
                 <a:latin typeface="Calibri"/>
               </a:rPr>
-              <a:t>BloodBridge - AI-assisted blood donor discovery</a:t>
+              <a:t>BloodBridge - AI-assisted blood donor discovery  ·  LIVE: https://bloodbridge-app.riteshnethi-art.workers.dev</a:t>
             </a:r>
           </a:p>
         </p:txBody>
@@ -5939,8 +5755,8 @@
         </p:nvSpPr>
         <p:spPr>
           <a:xfrm>
-            <a:off x="11247120" y="6473952"/>
-            <a:ext cx="548640" cy="274320"/>
+            <a:off x="10972800" y="6473952"/>
+            <a:ext cx="822960" cy="274320"/>
           </a:xfrm>
           <a:prstGeom prst="rect">
             <a:avLst/>
@@ -5965,7 +5781,7 @@
                 </a:solidFill>
                 <a:latin typeface="Calibri"/>
               </a:rPr>
-              <a:t>4 / 6</a:t>
+              <a:t>4 / 7</a:t>
             </a:r>
           </a:p>
         </p:txBody>
@@ -6797,7 +6613,7 @@
                 </a:solidFill>
                 <a:latin typeface="Calibri"/>
               </a:rPr>
-              <a:t>COMMUNITY ENGINE</a:t>
+              <a:t>LIVE NOW - NOT ON LOCALHOST</a:t>
             </a:r>
           </a:p>
         </p:txBody>
@@ -6836,7 +6652,7 @@
                 </a:solidFill>
                 <a:latin typeface="Calibri"/>
               </a:rPr>
-              <a:t>Rewards and referrals that keep donors engaged</a:t>
+              <a:t>The real product, running in production today</a:t>
             </a:r>
           </a:p>
         </p:txBody>
@@ -6919,7 +6735,7 @@
                 </a:solidFill>
                 <a:latin typeface="Calibri"/>
               </a:rPr>
-              <a:t>BloodBridge - AI-assisted blood donor discovery</a:t>
+              <a:t>BloodBridge - AI-assisted blood donor discovery  ·  LIVE: https://bloodbridge-app.riteshnethi-art.workers.dev</a:t>
             </a:r>
           </a:p>
         </p:txBody>
@@ -6932,8 +6748,8 @@
         </p:nvSpPr>
         <p:spPr>
           <a:xfrm>
-            <a:off x="11247120" y="6473952"/>
-            <a:ext cx="548640" cy="274320"/>
+            <a:off x="10972800" y="6473952"/>
+            <a:ext cx="822960" cy="274320"/>
           </a:xfrm>
           <a:prstGeom prst="rect">
             <a:avLst/>
@@ -6958,7 +6774,7 @@
                 </a:solidFill>
                 <a:latin typeface="Calibri"/>
               </a:rPr>
-              <a:t>5 / 6</a:t>
+              <a:t>5 / 7</a:t>
             </a:r>
           </a:p>
         </p:txBody>
@@ -6971,12 +6787,12 @@
         </p:nvSpPr>
         <p:spPr>
           <a:xfrm>
-            <a:off x="402336" y="1572768"/>
-            <a:ext cx="5486400" cy="4315968"/>
+            <a:off x="402336" y="1517904"/>
+            <a:ext cx="3611880" cy="4315968"/>
           </a:xfrm>
           <a:prstGeom prst="roundRect">
             <a:avLst>
-              <a:gd name="adj" fmla="val 6000"/>
+              <a:gd name="adj" fmla="val 5000"/>
             </a:avLst>
           </a:prstGeom>
           <a:solidFill>
@@ -7011,65 +6827,30 @@
           </a:p>
         </p:txBody>
       </p:sp>
-      <p:sp>
-        <p:nvSpPr>
-          <p:cNvPr id="8" name="Rounded Rectangle 7"/>
-          <p:cNvSpPr/>
-          <p:nvPr/>
-        </p:nvSpPr>
-        <p:spPr>
-          <a:xfrm>
-            <a:off x="402336" y="1572768"/>
-            <a:ext cx="5486400" cy="502920"/>
-          </a:xfrm>
-          <a:prstGeom prst="roundRect">
-            <a:avLst>
-              <a:gd name="adj" fmla="val 6000"/>
-            </a:avLst>
-          </a:prstGeom>
-          <a:solidFill>
-            <a:srgbClr val="15803D"/>
-          </a:solidFill>
-          <a:ln>
-            <a:noFill/>
-          </a:ln>
-          <a:effectLst/>
-        </p:spPr>
-        <p:style>
-          <a:lnRef idx="1">
-            <a:schemeClr val="accent1"/>
-          </a:lnRef>
-          <a:fillRef idx="3">
-            <a:schemeClr val="accent1"/>
-          </a:fillRef>
-          <a:effectRef idx="2">
-            <a:schemeClr val="accent1"/>
-          </a:effectRef>
-          <a:fontRef idx="minor">
-            <a:schemeClr val="lt1"/>
-          </a:fontRef>
-        </p:style>
-        <p:txBody>
-          <a:bodyPr rtlCol="0" anchor="ctr" wrap="square" lIns="228600" tIns="0" bIns="0"/>
-          <a:lstStyle/>
-          <a:p>
-            <a:pPr algn="l">
-              <a:spcAft>
-                <a:spcPts val="0"/>
-              </a:spcAft>
-            </a:pPr>
-            <a:r>
-              <a:rPr sz="1350" b="1">
-                <a:solidFill>
-                  <a:srgbClr val="FFFFFF"/>
-                </a:solidFill>
-                <a:latin typeface="Calibri"/>
-              </a:rPr>
-              <a:t>COMMUNITY REWARDS</a:t>
-            </a:r>
-          </a:p>
-        </p:txBody>
-      </p:sp>
+      <p:pic>
+        <p:nvPicPr>
+          <p:cNvPr id="8" name="Picture 7" descr="shot_landing_card.jpg"/>
+          <p:cNvPicPr>
+            <a:picLocks noChangeAspect="1"/>
+          </p:cNvPicPr>
+          <p:nvPr/>
+        </p:nvPicPr>
+        <p:blipFill>
+          <a:blip r:embed="rId2"/>
+          <a:stretch>
+            <a:fillRect/>
+          </a:stretch>
+        </p:blipFill>
+        <p:spPr>
+          <a:xfrm>
+            <a:off x="457200" y="1572768"/>
+            <a:ext cx="3502152" cy="3327044"/>
+          </a:xfrm>
+          <a:prstGeom prst="rect">
+            <a:avLst/>
+          </a:prstGeom>
+        </p:spPr>
+      </p:pic>
       <p:sp>
         <p:nvSpPr>
           <p:cNvPr id="9" name="TextBox 8"/>
@@ -7078,8 +6859,8 @@
         </p:nvSpPr>
         <p:spPr>
           <a:xfrm>
-            <a:off x="685800" y="2258568"/>
-            <a:ext cx="4983480" cy="3493008"/>
+            <a:off x="530352" y="4956048"/>
+            <a:ext cx="3355848" cy="841248"/>
           </a:xfrm>
           <a:prstGeom prst="rect">
             <a:avLst/>
@@ -7094,137 +6875,33 @@
           <a:p>
             <a:pPr algn="l">
               <a:spcAft>
-                <a:spcPts val="900"/>
-              </a:spcAft>
-            </a:pPr>
-            <a:r>
-              <a:rPr sz="1200" b="1">
-                <a:solidFill>
-                  <a:srgbClr val="C81E1E"/>
-                </a:solidFill>
-                <a:latin typeface="Calibri"/>
-              </a:rPr>
-              <a:t>•  </a:t>
-            </a:r>
-            <a:r>
-              <a:rPr sz="1200" b="1">
+                <a:spcPts val="300"/>
+              </a:spcAft>
+            </a:pPr>
+            <a:r>
+              <a:rPr sz="1150" b="1">
                 <a:solidFill>
                   <a:srgbClr val="1C1917"/>
                 </a:solidFill>
                 <a:latin typeface="Calibri"/>
               </a:rPr>
-              <a:t>Earn points: </a:t>
-            </a:r>
-            <a:r>
-              <a:rPr sz="1200" b="0">
-                <a:solidFill>
-                  <a:srgbClr val="1C1917"/>
-                </a:solidFill>
-                <a:latin typeface="Calibri"/>
-              </a:rPr>
-              <a:t>for community-friendly actions: complete profile, respond to requests, invite friends, learn donation facts</a:t>
+              <a:t>Landing &amp; onboarding</a:t>
             </a:r>
           </a:p>
           <a:p>
             <a:pPr algn="l">
               <a:spcAft>
-                <a:spcPts val="900"/>
-              </a:spcAft>
-            </a:pPr>
-            <a:r>
-              <a:rPr sz="1200" b="1">
-                <a:solidFill>
-                  <a:srgbClr val="C81E1E"/>
-                </a:solidFill>
-                <a:latin typeface="Calibri"/>
-              </a:rPr>
-              <a:t>•  </a:t>
-            </a:r>
-            <a:r>
-              <a:rPr sz="1200" b="1">
-                <a:solidFill>
-                  <a:srgbClr val="1C1917"/>
-                </a:solidFill>
-                <a:latin typeface="Calibri"/>
-              </a:rPr>
-              <a:t>Redeem: </a:t>
-            </a:r>
-            <a:r>
-              <a:rPr sz="1200" b="0">
-                <a:solidFill>
-                  <a:srgbClr val="1C1917"/>
-                </a:solidFill>
-                <a:latin typeface="Calibri"/>
-              </a:rPr>
-              <a:t>for partner offers from verified local partners - always labeled “Demo Partner” in the demo</a:t>
-            </a:r>
-          </a:p>
-          <a:p>
-            <a:pPr algn="l">
-              <a:spcAft>
-                <a:spcPts val="900"/>
-              </a:spcAft>
-            </a:pPr>
-            <a:r>
-              <a:rPr sz="1200" b="1">
-                <a:solidFill>
-                  <a:srgbClr val="C81E1E"/>
-                </a:solidFill>
-                <a:latin typeface="Calibri"/>
-              </a:rPr>
-              <a:t>•  </a:t>
-            </a:r>
-            <a:r>
-              <a:rPr sz="1200" b="1">
-                <a:solidFill>
-                  <a:srgbClr val="1C1917"/>
-                </a:solidFill>
-                <a:latin typeface="Calibri"/>
-              </a:rPr>
-              <a:t>Transactional claims: </a:t>
-            </a:r>
-            <a:r>
-              <a:rPr sz="1200" b="0">
-                <a:solidFill>
-                  <a:srgbClr val="1C1917"/>
-                </a:solidFill>
-                <a:latin typeface="Calibri"/>
-              </a:rPr>
-              <a:t>reserve → verify → redeem; every step is audited and race-safe</a:t>
-            </a:r>
-          </a:p>
-          <a:p>
-            <a:pPr algn="l">
-              <a:spcAft>
-                <a:spcPts val="900"/>
-              </a:spcAft>
-            </a:pPr>
-            <a:r>
-              <a:rPr sz="1200" b="1">
-                <a:solidFill>
-                  <a:srgbClr val="C81E1E"/>
-                </a:solidFill>
-                <a:latin typeface="Calibri"/>
-              </a:rPr>
-              <a:t>•  </a:t>
-            </a:r>
-            <a:r>
-              <a:rPr sz="1200" b="1">
-                <a:solidFill>
-                  <a:srgbClr val="1C1917"/>
-                </a:solidFill>
-                <a:latin typeface="Calibri"/>
-              </a:rPr>
-              <a:t>Never cash: </a:t>
-            </a:r>
-            <a:r>
-              <a:rPr sz="1200" b="0">
-                <a:solidFill>
-                  <a:srgbClr val="1C1917"/>
-                </a:solidFill>
-                <a:latin typeface="Calibri"/>
-              </a:rPr>
-              <a:t>no money, no gift cards, and points are never tied to donating blood - engagement only</a:t>
+                <a:spcPts val="0"/>
+              </a:spcAft>
+            </a:pPr>
+            <a:r>
+              <a:rPr sz="900" b="0">
+                <a:solidFill>
+                  <a:srgbClr val="57534E"/>
+                </a:solidFill>
+                <a:latin typeface="Calibri"/>
+              </a:rPr>
+              <a:t>Compatibility table, safety notice and a 4-step tour - a stranger can act in 60 seconds</a:t>
             </a:r>
           </a:p>
         </p:txBody>
@@ -7237,12 +6914,12 @@
         </p:nvSpPr>
         <p:spPr>
           <a:xfrm>
-            <a:off x="6300216" y="1572768"/>
-            <a:ext cx="5486400" cy="4315968"/>
+            <a:off x="4288536" y="1517904"/>
+            <a:ext cx="3611880" cy="4315968"/>
           </a:xfrm>
           <a:prstGeom prst="roundRect">
             <a:avLst>
-              <a:gd name="adj" fmla="val 6000"/>
+              <a:gd name="adj" fmla="val 5000"/>
             </a:avLst>
           </a:prstGeom>
           <a:solidFill>
@@ -7277,27 +6954,108 @@
           </a:p>
         </p:txBody>
       </p:sp>
-      <p:sp>
-        <p:nvSpPr>
-          <p:cNvPr id="11" name="Rounded Rectangle 10"/>
+      <p:pic>
+        <p:nvPicPr>
+          <p:cNvPr id="11" name="Picture 10" descr="shot_assistant_gate_card.jpg"/>
+          <p:cNvPicPr>
+            <a:picLocks noChangeAspect="1"/>
+          </p:cNvPicPr>
+          <p:nvPr/>
+        </p:nvPicPr>
+        <p:blipFill>
+          <a:blip r:embed="rId3"/>
+          <a:stretch>
+            <a:fillRect/>
+          </a:stretch>
+        </p:blipFill>
+        <p:spPr>
+          <a:xfrm>
+            <a:off x="4343400" y="1572768"/>
+            <a:ext cx="3502152" cy="2451506"/>
+          </a:xfrm>
+          <a:prstGeom prst="rect">
+            <a:avLst/>
+          </a:prstGeom>
+        </p:spPr>
+      </p:pic>
+      <p:sp>
+        <p:nvSpPr>
+          <p:cNvPr id="12" name="TextBox 11"/>
+          <p:cNvSpPr txBox="1"/>
+          <p:nvPr/>
+        </p:nvSpPr>
+        <p:spPr>
+          <a:xfrm>
+            <a:off x="4416552" y="4097426"/>
+            <a:ext cx="3355848" cy="841248"/>
+          </a:xfrm>
+          <a:prstGeom prst="rect">
+            <a:avLst/>
+          </a:prstGeom>
+          <a:noFill/>
+        </p:spPr>
+        <p:txBody>
+          <a:bodyPr wrap="square" anchor="t" lIns="0" rIns="0" tIns="0" bIns="0">
+            <a:spAutoFit/>
+          </a:bodyPr>
+          <a:lstStyle/>
+          <a:p>
+            <a:pPr algn="l">
+              <a:spcAft>
+                <a:spcPts val="300"/>
+              </a:spcAft>
+            </a:pPr>
+            <a:r>
+              <a:rPr sz="1150" b="1">
+                <a:solidFill>
+                  <a:srgbClr val="1C1917"/>
+                </a:solidFill>
+                <a:latin typeface="Calibri"/>
+              </a:rPr>
+              <a:t>Assistant confirmation gate</a:t>
+            </a:r>
+          </a:p>
+          <a:p>
+            <a:pPr algn="l">
+              <a:spcAft>
+                <a:spcPts val="0"/>
+              </a:spcAft>
+            </a:pPr>
+            <a:r>
+              <a:rPr sz="900" b="0">
+                <a:solidFill>
+                  <a:srgbClr val="57534E"/>
+                </a:solidFill>
+                <a:latin typeface="Calibri"/>
+              </a:rPr>
+              <a:t>Full structured summary with per-field edit commands - nothing submits without explicit approval</a:t>
+            </a:r>
+          </a:p>
+        </p:txBody>
+      </p:sp>
+      <p:sp>
+        <p:nvSpPr>
+          <p:cNvPr id="13" name="Rounded Rectangle 12"/>
           <p:cNvSpPr/>
           <p:nvPr/>
         </p:nvSpPr>
         <p:spPr>
           <a:xfrm>
-            <a:off x="6300216" y="1572768"/>
-            <a:ext cx="5486400" cy="502920"/>
+            <a:off x="8174736" y="1517904"/>
+            <a:ext cx="3611880" cy="4315968"/>
           </a:xfrm>
           <a:prstGeom prst="roundRect">
             <a:avLst>
-              <a:gd name="adj" fmla="val 6000"/>
+              <a:gd name="adj" fmla="val 5000"/>
             </a:avLst>
           </a:prstGeom>
           <a:solidFill>
-            <a:srgbClr val="C81E1E"/>
+            <a:srgbClr val="FFFFFF"/>
           </a:solidFill>
-          <a:ln>
-            <a:noFill/>
+          <a:ln w="15875">
+            <a:solidFill>
+              <a:srgbClr val="E7E5E4"/>
+            </a:solidFill>
           </a:ln>
           <a:effectLst/>
         </p:spPr>
@@ -7316,661 +7074,105 @@
           </a:fontRef>
         </p:style>
         <p:txBody>
-          <a:bodyPr rtlCol="0" anchor="ctr" wrap="square" lIns="228600" tIns="0" bIns="0"/>
+          <a:bodyPr rtlCol="0" anchor="ctr"/>
+          <a:lstStyle/>
+          <a:p>
+            <a:pPr algn="ctr"/>
+          </a:p>
+        </p:txBody>
+      </p:sp>
+      <p:pic>
+        <p:nvPicPr>
+          <p:cNvPr id="14" name="Picture 13" descr="shot_matches_card.jpg"/>
+          <p:cNvPicPr>
+            <a:picLocks noChangeAspect="1"/>
+          </p:cNvPicPr>
+          <p:nvPr/>
+        </p:nvPicPr>
+        <p:blipFill>
+          <a:blip r:embed="rId4"/>
+          <a:stretch>
+            <a:fillRect/>
+          </a:stretch>
+        </p:blipFill>
+        <p:spPr>
+          <a:xfrm>
+            <a:off x="8229600" y="1572768"/>
+            <a:ext cx="3502152" cy="3677260"/>
+          </a:xfrm>
+          <a:prstGeom prst="rect">
+            <a:avLst/>
+          </a:prstGeom>
+        </p:spPr>
+      </p:pic>
+      <p:sp>
+        <p:nvSpPr>
+          <p:cNvPr id="15" name="TextBox 14"/>
+          <p:cNvSpPr txBox="1"/>
+          <p:nvPr/>
+        </p:nvSpPr>
+        <p:spPr>
+          <a:xfrm>
+            <a:off x="8302752" y="4956048"/>
+            <a:ext cx="3355848" cy="841248"/>
+          </a:xfrm>
+          <a:prstGeom prst="rect">
+            <a:avLst/>
+          </a:prstGeom>
+          <a:noFill/>
+        </p:spPr>
+        <p:txBody>
+          <a:bodyPr wrap="square" anchor="t" lIns="0" rIns="0" tIns="0" bIns="0">
+            <a:spAutoFit/>
+          </a:bodyPr>
           <a:lstStyle/>
           <a:p>
             <a:pPr algn="l">
               <a:spcAft>
+                <a:spcPts val="300"/>
+              </a:spcAft>
+            </a:pPr>
+            <a:r>
+              <a:rPr sz="1150" b="1">
+                <a:solidFill>
+                  <a:srgbClr val="1C1917"/>
+                </a:solidFill>
+                <a:latin typeface="Calibri"/>
+              </a:rPr>
+              <a:t>Ranked matches, explained</a:t>
+            </a:r>
+          </a:p>
+          <a:p>
+            <a:pPr algn="l">
+              <a:spcAft>
                 <a:spcPts val="0"/>
               </a:spcAft>
             </a:pPr>
             <a:r>
-              <a:rPr sz="1350" b="1">
-                <a:solidFill>
-                  <a:srgbClr val="FFFFFF"/>
-                </a:solidFill>
-                <a:latin typeface="Calibri"/>
-              </a:rPr>
-              <a:t>REFERRAL PROGRAM - TRACKED FUNNEL</a:t>
-            </a:r>
-          </a:p>
-        </p:txBody>
-      </p:sp>
-      <p:sp>
-        <p:nvSpPr>
-          <p:cNvPr id="12" name="Rounded Rectangle 11"/>
+              <a:rPr sz="900" b="0">
+                <a:solidFill>
+                  <a:srgbClr val="57534E"/>
+                </a:solidFill>
+                <a:latin typeface="Calibri"/>
+              </a:rPr>
+              <a:t>Score, distance, availability and a per-donor explanation - contact stays consent-gated</a:t>
+            </a:r>
+          </a:p>
+        </p:txBody>
+      </p:sp>
+      <p:sp>
+        <p:nvSpPr>
+          <p:cNvPr id="16" name="Rounded Rectangle 15"/>
           <p:cNvSpPr/>
           <p:nvPr/>
         </p:nvSpPr>
         <p:spPr>
           <a:xfrm>
-            <a:off x="6528816" y="2194560"/>
-            <a:ext cx="3291840" cy="420624"/>
+            <a:off x="402336" y="5989320"/>
+            <a:ext cx="11384280" cy="420624"/>
           </a:xfrm>
           <a:prstGeom prst="roundRect">
-            <a:avLst>
-              <a:gd name="adj" fmla="val 22000"/>
-            </a:avLst>
-          </a:prstGeom>
-          <a:solidFill>
-            <a:srgbClr val="FAFAF9"/>
-          </a:solidFill>
-          <a:ln w="12700">
-            <a:solidFill>
-              <a:srgbClr val="E7E5E4"/>
-            </a:solidFill>
-          </a:ln>
-          <a:effectLst/>
-        </p:spPr>
-        <p:style>
-          <a:lnRef idx="1">
-            <a:schemeClr val="accent1"/>
-          </a:lnRef>
-          <a:fillRef idx="3">
-            <a:schemeClr val="accent1"/>
-          </a:fillRef>
-          <a:effectRef idx="2">
-            <a:schemeClr val="accent1"/>
-          </a:effectRef>
-          <a:fontRef idx="minor">
-            <a:schemeClr val="lt1"/>
-          </a:fontRef>
-        </p:style>
-        <p:txBody>
-          <a:bodyPr rtlCol="0" anchor="ctr" wrap="square" lIns="128016" rIns="54864" tIns="0" bIns="0"/>
-          <a:lstStyle/>
-          <a:p>
-            <a:pPr algn="l">
-              <a:spcAft>
-                <a:spcPts val="0"/>
-              </a:spcAft>
-            </a:pPr>
-            <a:r>
-              <a:rPr sz="1050" b="0">
-                <a:solidFill>
-                  <a:srgbClr val="1C1917"/>
-                </a:solidFill>
-                <a:latin typeface="Calibri"/>
-              </a:rPr>
-              <a:t>Share link  BLOODBRIDGE-XXXXX</a:t>
-            </a:r>
-          </a:p>
-        </p:txBody>
-      </p:sp>
-      <p:sp>
-        <p:nvSpPr>
-          <p:cNvPr id="13" name="Oval 12"/>
-          <p:cNvSpPr/>
-          <p:nvPr/>
-        </p:nvSpPr>
-        <p:spPr>
-          <a:xfrm>
-            <a:off x="6309359" y="2249424"/>
-            <a:ext cx="310896" cy="310896"/>
-          </a:xfrm>
-          <a:prstGeom prst="ellipse">
             <a:avLst/>
-          </a:prstGeom>
-          <a:solidFill>
-            <a:srgbClr val="C81E1E"/>
-          </a:solidFill>
-          <a:ln>
-            <a:noFill/>
-          </a:ln>
-          <a:effectLst/>
-        </p:spPr>
-        <p:style>
-          <a:lnRef idx="1">
-            <a:schemeClr val="accent1"/>
-          </a:lnRef>
-          <a:fillRef idx="3">
-            <a:schemeClr val="accent1"/>
-          </a:fillRef>
-          <a:effectRef idx="2">
-            <a:schemeClr val="accent1"/>
-          </a:effectRef>
-          <a:fontRef idx="minor">
-            <a:schemeClr val="lt1"/>
-          </a:fontRef>
-        </p:style>
-        <p:txBody>
-          <a:bodyPr rtlCol="0" anchor="ctr" wrap="square" lIns="54864" rIns="54864" tIns="36576" bIns="36576"/>
-          <a:lstStyle/>
-          <a:p>
-            <a:pPr algn="ctr">
-              <a:spcAft>
-                <a:spcPts val="0"/>
-              </a:spcAft>
-            </a:pPr>
-            <a:r>
-              <a:rPr sz="1100" b="1">
-                <a:solidFill>
-                  <a:srgbClr val="FFFFFF"/>
-                </a:solidFill>
-                <a:latin typeface="Calibri"/>
-              </a:rPr>
-              <a:t>1</a:t>
-            </a:r>
-          </a:p>
-        </p:txBody>
-      </p:sp>
-      <p:cxnSp>
-        <p:nvCxnSpPr>
-          <p:cNvPr id="14" name="Connector 13"/>
-          <p:cNvCxnSpPr/>
-          <p:nvPr/>
-        </p:nvCxnSpPr>
-        <p:spPr>
-          <a:xfrm>
-            <a:off x="8174736" y="2624327"/>
-            <a:ext cx="0" cy="128017"/>
-          </a:xfrm>
-          <a:prstGeom prst="line">
-            <a:avLst/>
-          </a:prstGeom>
-          <a:ln w="19050">
-            <a:solidFill>
-              <a:srgbClr val="C81E1E"/>
-            </a:solidFill>
-            <a:tailEnd type="triangle" w="med" len="med"/>
-          </a:ln>
-          <a:effectLst/>
-        </p:spPr>
-        <p:style>
-          <a:lnRef idx="2">
-            <a:schemeClr val="accent1"/>
-          </a:lnRef>
-          <a:fillRef idx="0">
-            <a:schemeClr val="accent1"/>
-          </a:fillRef>
-          <a:effectRef idx="1">
-            <a:schemeClr val="accent1"/>
-          </a:effectRef>
-          <a:fontRef idx="minor">
-            <a:schemeClr val="tx1"/>
-          </a:fontRef>
-        </p:style>
-      </p:cxnSp>
-      <p:sp>
-        <p:nvSpPr>
-          <p:cNvPr id="15" name="Rounded Rectangle 14"/>
-          <p:cNvSpPr/>
-          <p:nvPr/>
-        </p:nvSpPr>
-        <p:spPr>
-          <a:xfrm>
-            <a:off x="6528816" y="2770632"/>
-            <a:ext cx="3291840" cy="420624"/>
-          </a:xfrm>
-          <a:prstGeom prst="roundRect">
-            <a:avLst>
-              <a:gd name="adj" fmla="val 22000"/>
-            </a:avLst>
-          </a:prstGeom>
-          <a:solidFill>
-            <a:srgbClr val="FAFAF9"/>
-          </a:solidFill>
-          <a:ln w="12700">
-            <a:solidFill>
-              <a:srgbClr val="E7E5E4"/>
-            </a:solidFill>
-          </a:ln>
-          <a:effectLst/>
-        </p:spPr>
-        <p:style>
-          <a:lnRef idx="1">
-            <a:schemeClr val="accent1"/>
-          </a:lnRef>
-          <a:fillRef idx="3">
-            <a:schemeClr val="accent1"/>
-          </a:fillRef>
-          <a:effectRef idx="2">
-            <a:schemeClr val="accent1"/>
-          </a:effectRef>
-          <a:fontRef idx="minor">
-            <a:schemeClr val="lt1"/>
-          </a:fontRef>
-        </p:style>
-        <p:txBody>
-          <a:bodyPr rtlCol="0" anchor="ctr" wrap="square" lIns="128016" rIns="54864" tIns="0" bIns="0"/>
-          <a:lstStyle/>
-          <a:p>
-            <a:pPr algn="l">
-              <a:spcAft>
-                <a:spcPts val="0"/>
-              </a:spcAft>
-            </a:pPr>
-            <a:r>
-              <a:rPr sz="1050" b="0">
-                <a:solidFill>
-                  <a:srgbClr val="1C1917"/>
-                </a:solidFill>
-                <a:latin typeface="Calibri"/>
-              </a:rPr>
-              <a:t>Friend opens &amp; registers</a:t>
-            </a:r>
-          </a:p>
-        </p:txBody>
-      </p:sp>
-      <p:sp>
-        <p:nvSpPr>
-          <p:cNvPr id="16" name="Oval 15"/>
-          <p:cNvSpPr/>
-          <p:nvPr/>
-        </p:nvSpPr>
-        <p:spPr>
-          <a:xfrm>
-            <a:off x="6309359" y="2825496"/>
-            <a:ext cx="310896" cy="310896"/>
-          </a:xfrm>
-          <a:prstGeom prst="ellipse">
-            <a:avLst/>
-          </a:prstGeom>
-          <a:solidFill>
-            <a:srgbClr val="C81E1E"/>
-          </a:solidFill>
-          <a:ln>
-            <a:noFill/>
-          </a:ln>
-          <a:effectLst/>
-        </p:spPr>
-        <p:style>
-          <a:lnRef idx="1">
-            <a:schemeClr val="accent1"/>
-          </a:lnRef>
-          <a:fillRef idx="3">
-            <a:schemeClr val="accent1"/>
-          </a:fillRef>
-          <a:effectRef idx="2">
-            <a:schemeClr val="accent1"/>
-          </a:effectRef>
-          <a:fontRef idx="minor">
-            <a:schemeClr val="lt1"/>
-          </a:fontRef>
-        </p:style>
-        <p:txBody>
-          <a:bodyPr rtlCol="0" anchor="ctr" wrap="square" lIns="54864" rIns="54864" tIns="36576" bIns="36576"/>
-          <a:lstStyle/>
-          <a:p>
-            <a:pPr algn="ctr">
-              <a:spcAft>
-                <a:spcPts val="0"/>
-              </a:spcAft>
-            </a:pPr>
-            <a:r>
-              <a:rPr sz="1100" b="1">
-                <a:solidFill>
-                  <a:srgbClr val="FFFFFF"/>
-                </a:solidFill>
-                <a:latin typeface="Calibri"/>
-              </a:rPr>
-              <a:t>2</a:t>
-            </a:r>
-          </a:p>
-        </p:txBody>
-      </p:sp>
-      <p:cxnSp>
-        <p:nvCxnSpPr>
-          <p:cNvPr id="17" name="Connector 16"/>
-          <p:cNvCxnSpPr/>
-          <p:nvPr/>
-        </p:nvCxnSpPr>
-        <p:spPr>
-          <a:xfrm>
-            <a:off x="8174736" y="3200399"/>
-            <a:ext cx="0" cy="128016"/>
-          </a:xfrm>
-          <a:prstGeom prst="line">
-            <a:avLst/>
-          </a:prstGeom>
-          <a:ln w="19050">
-            <a:solidFill>
-              <a:srgbClr val="C81E1E"/>
-            </a:solidFill>
-            <a:tailEnd type="triangle" w="med" len="med"/>
-          </a:ln>
-          <a:effectLst/>
-        </p:spPr>
-        <p:style>
-          <a:lnRef idx="2">
-            <a:schemeClr val="accent1"/>
-          </a:lnRef>
-          <a:fillRef idx="0">
-            <a:schemeClr val="accent1"/>
-          </a:fillRef>
-          <a:effectRef idx="1">
-            <a:schemeClr val="accent1"/>
-          </a:effectRef>
-          <a:fontRef idx="minor">
-            <a:schemeClr val="tx1"/>
-          </a:fontRef>
-        </p:style>
-      </p:cxnSp>
-      <p:sp>
-        <p:nvSpPr>
-          <p:cNvPr id="18" name="Rounded Rectangle 17"/>
-          <p:cNvSpPr/>
-          <p:nvPr/>
-        </p:nvSpPr>
-        <p:spPr>
-          <a:xfrm>
-            <a:off x="6528816" y="3346703"/>
-            <a:ext cx="3291840" cy="420624"/>
-          </a:xfrm>
-          <a:prstGeom prst="roundRect">
-            <a:avLst>
-              <a:gd name="adj" fmla="val 22000"/>
-            </a:avLst>
-          </a:prstGeom>
-          <a:solidFill>
-            <a:srgbClr val="FAFAF9"/>
-          </a:solidFill>
-          <a:ln w="12700">
-            <a:solidFill>
-              <a:srgbClr val="E7E5E4"/>
-            </a:solidFill>
-          </a:ln>
-          <a:effectLst/>
-        </p:spPr>
-        <p:style>
-          <a:lnRef idx="1">
-            <a:schemeClr val="accent1"/>
-          </a:lnRef>
-          <a:fillRef idx="3">
-            <a:schemeClr val="accent1"/>
-          </a:fillRef>
-          <a:effectRef idx="2">
-            <a:schemeClr val="accent1"/>
-          </a:effectRef>
-          <a:fontRef idx="minor">
-            <a:schemeClr val="lt1"/>
-          </a:fontRef>
-        </p:style>
-        <p:txBody>
-          <a:bodyPr rtlCol="0" anchor="ctr" wrap="square" lIns="128016" rIns="54864" tIns="0" bIns="0"/>
-          <a:lstStyle/>
-          <a:p>
-            <a:pPr algn="l">
-              <a:spcAft>
-                <a:spcPts val="0"/>
-              </a:spcAft>
-            </a:pPr>
-            <a:r>
-              <a:rPr sz="1050" b="0">
-                <a:solidFill>
-                  <a:srgbClr val="1C1917"/>
-                </a:solidFill>
-                <a:latin typeface="Calibri"/>
-              </a:rPr>
-              <a:t>Profile completed</a:t>
-            </a:r>
-          </a:p>
-        </p:txBody>
-      </p:sp>
-      <p:sp>
-        <p:nvSpPr>
-          <p:cNvPr id="19" name="Oval 18"/>
-          <p:cNvSpPr/>
-          <p:nvPr/>
-        </p:nvSpPr>
-        <p:spPr>
-          <a:xfrm>
-            <a:off x="6309359" y="3401568"/>
-            <a:ext cx="310896" cy="310896"/>
-          </a:xfrm>
-          <a:prstGeom prst="ellipse">
-            <a:avLst/>
-          </a:prstGeom>
-          <a:solidFill>
-            <a:srgbClr val="C81E1E"/>
-          </a:solidFill>
-          <a:ln>
-            <a:noFill/>
-          </a:ln>
-          <a:effectLst/>
-        </p:spPr>
-        <p:style>
-          <a:lnRef idx="1">
-            <a:schemeClr val="accent1"/>
-          </a:lnRef>
-          <a:fillRef idx="3">
-            <a:schemeClr val="accent1"/>
-          </a:fillRef>
-          <a:effectRef idx="2">
-            <a:schemeClr val="accent1"/>
-          </a:effectRef>
-          <a:fontRef idx="minor">
-            <a:schemeClr val="lt1"/>
-          </a:fontRef>
-        </p:style>
-        <p:txBody>
-          <a:bodyPr rtlCol="0" anchor="ctr" wrap="square" lIns="54864" rIns="54864" tIns="36576" bIns="36576"/>
-          <a:lstStyle/>
-          <a:p>
-            <a:pPr algn="ctr">
-              <a:spcAft>
-                <a:spcPts val="0"/>
-              </a:spcAft>
-            </a:pPr>
-            <a:r>
-              <a:rPr sz="1100" b="1">
-                <a:solidFill>
-                  <a:srgbClr val="FFFFFF"/>
-                </a:solidFill>
-                <a:latin typeface="Calibri"/>
-              </a:rPr>
-              <a:t>3</a:t>
-            </a:r>
-          </a:p>
-        </p:txBody>
-      </p:sp>
-      <p:cxnSp>
-        <p:nvCxnSpPr>
-          <p:cNvPr id="20" name="Connector 19"/>
-          <p:cNvCxnSpPr/>
-          <p:nvPr/>
-        </p:nvCxnSpPr>
-        <p:spPr>
-          <a:xfrm>
-            <a:off x="8174736" y="3776472"/>
-            <a:ext cx="0" cy="128016"/>
-          </a:xfrm>
-          <a:prstGeom prst="line">
-            <a:avLst/>
-          </a:prstGeom>
-          <a:ln w="19050">
-            <a:solidFill>
-              <a:srgbClr val="C81E1E"/>
-            </a:solidFill>
-            <a:tailEnd type="triangle" w="med" len="med"/>
-          </a:ln>
-          <a:effectLst/>
-        </p:spPr>
-        <p:style>
-          <a:lnRef idx="2">
-            <a:schemeClr val="accent1"/>
-          </a:lnRef>
-          <a:fillRef idx="0">
-            <a:schemeClr val="accent1"/>
-          </a:fillRef>
-          <a:effectRef idx="1">
-            <a:schemeClr val="accent1"/>
-          </a:effectRef>
-          <a:fontRef idx="minor">
-            <a:schemeClr val="tx1"/>
-          </a:fontRef>
-        </p:style>
-      </p:cxnSp>
-      <p:sp>
-        <p:nvSpPr>
-          <p:cNvPr id="21" name="Rounded Rectangle 20"/>
-          <p:cNvSpPr/>
-          <p:nvPr/>
-        </p:nvSpPr>
-        <p:spPr>
-          <a:xfrm>
-            <a:off x="6528816" y="3922776"/>
-            <a:ext cx="3291840" cy="420624"/>
-          </a:xfrm>
-          <a:prstGeom prst="roundRect">
-            <a:avLst>
-              <a:gd name="adj" fmla="val 22000"/>
-            </a:avLst>
-          </a:prstGeom>
-          <a:solidFill>
-            <a:srgbClr val="FAFAF9"/>
-          </a:solidFill>
-          <a:ln w="12700">
-            <a:solidFill>
-              <a:srgbClr val="E7E5E4"/>
-            </a:solidFill>
-          </a:ln>
-          <a:effectLst/>
-        </p:spPr>
-        <p:style>
-          <a:lnRef idx="1">
-            <a:schemeClr val="accent1"/>
-          </a:lnRef>
-          <a:fillRef idx="3">
-            <a:schemeClr val="accent1"/>
-          </a:fillRef>
-          <a:effectRef idx="2">
-            <a:schemeClr val="accent1"/>
-          </a:effectRef>
-          <a:fontRef idx="minor">
-            <a:schemeClr val="lt1"/>
-          </a:fontRef>
-        </p:style>
-        <p:txBody>
-          <a:bodyPr rtlCol="0" anchor="ctr" wrap="square" lIns="128016" rIns="54864" tIns="0" bIns="0"/>
-          <a:lstStyle/>
-          <a:p>
-            <a:pPr algn="l">
-              <a:spcAft>
-                <a:spcPts val="0"/>
-              </a:spcAft>
-            </a:pPr>
-            <a:r>
-              <a:rPr sz="1050" b="0">
-                <a:solidFill>
-                  <a:srgbClr val="1C1917"/>
-                </a:solidFill>
-                <a:latin typeface="Calibri"/>
-              </a:rPr>
-              <a:t>First request or donor response</a:t>
-            </a:r>
-          </a:p>
-        </p:txBody>
-      </p:sp>
-      <p:sp>
-        <p:nvSpPr>
-          <p:cNvPr id="22" name="Oval 21"/>
-          <p:cNvSpPr/>
-          <p:nvPr/>
-        </p:nvSpPr>
-        <p:spPr>
-          <a:xfrm>
-            <a:off x="6309359" y="3977639"/>
-            <a:ext cx="310896" cy="310896"/>
-          </a:xfrm>
-          <a:prstGeom prst="ellipse">
-            <a:avLst/>
-          </a:prstGeom>
-          <a:solidFill>
-            <a:srgbClr val="C81E1E"/>
-          </a:solidFill>
-          <a:ln>
-            <a:noFill/>
-          </a:ln>
-          <a:effectLst/>
-        </p:spPr>
-        <p:style>
-          <a:lnRef idx="1">
-            <a:schemeClr val="accent1"/>
-          </a:lnRef>
-          <a:fillRef idx="3">
-            <a:schemeClr val="accent1"/>
-          </a:fillRef>
-          <a:effectRef idx="2">
-            <a:schemeClr val="accent1"/>
-          </a:effectRef>
-          <a:fontRef idx="minor">
-            <a:schemeClr val="lt1"/>
-          </a:fontRef>
-        </p:style>
-        <p:txBody>
-          <a:bodyPr rtlCol="0" anchor="ctr" wrap="square" lIns="54864" rIns="54864" tIns="36576" bIns="36576"/>
-          <a:lstStyle/>
-          <a:p>
-            <a:pPr algn="ctr">
-              <a:spcAft>
-                <a:spcPts val="0"/>
-              </a:spcAft>
-            </a:pPr>
-            <a:r>
-              <a:rPr sz="1100" b="1">
-                <a:solidFill>
-                  <a:srgbClr val="FFFFFF"/>
-                </a:solidFill>
-                <a:latin typeface="Calibri"/>
-              </a:rPr>
-              <a:t>4</a:t>
-            </a:r>
-          </a:p>
-        </p:txBody>
-      </p:sp>
-      <p:cxnSp>
-        <p:nvCxnSpPr>
-          <p:cNvPr id="23" name="Connector 22"/>
-          <p:cNvCxnSpPr/>
-          <p:nvPr/>
-        </p:nvCxnSpPr>
-        <p:spPr>
-          <a:xfrm>
-            <a:off x="8174736" y="4352544"/>
-            <a:ext cx="0" cy="128016"/>
-          </a:xfrm>
-          <a:prstGeom prst="line">
-            <a:avLst/>
-          </a:prstGeom>
-          <a:ln w="19050">
-            <a:solidFill>
-              <a:srgbClr val="C81E1E"/>
-            </a:solidFill>
-            <a:tailEnd type="triangle" w="med" len="med"/>
-          </a:ln>
-          <a:effectLst/>
-        </p:spPr>
-        <p:style>
-          <a:lnRef idx="2">
-            <a:schemeClr val="accent1"/>
-          </a:lnRef>
-          <a:fillRef idx="0">
-            <a:schemeClr val="accent1"/>
-          </a:fillRef>
-          <a:effectRef idx="1">
-            <a:schemeClr val="accent1"/>
-          </a:effectRef>
-          <a:fontRef idx="minor">
-            <a:schemeClr val="tx1"/>
-          </a:fontRef>
-        </p:style>
-      </p:cxnSp>
-      <p:sp>
-        <p:nvSpPr>
-          <p:cNvPr id="24" name="Rounded Rectangle 23"/>
-          <p:cNvSpPr/>
-          <p:nvPr/>
-        </p:nvSpPr>
-        <p:spPr>
-          <a:xfrm>
-            <a:off x="6528816" y="4498848"/>
-            <a:ext cx="3291840" cy="420624"/>
-          </a:xfrm>
-          <a:prstGeom prst="roundRect">
-            <a:avLst>
-              <a:gd name="adj" fmla="val 22000"/>
-            </a:avLst>
           </a:prstGeom>
           <a:solidFill>
             <a:srgbClr val="ECFCF3"/>
@@ -7997,195 +7199,31 @@
           </a:fontRef>
         </p:style>
         <p:txBody>
-          <a:bodyPr rtlCol="0" anchor="ctr" wrap="square" lIns="128016" rIns="54864" tIns="0" bIns="0"/>
-          <a:lstStyle/>
-          <a:p>
-            <a:pPr algn="l">
+          <a:bodyPr rtlCol="0" anchor="ctr" wrap="square" lIns="54864" rIns="54864" tIns="36576" bIns="36576"/>
+          <a:lstStyle/>
+          <a:p>
+            <a:pPr algn="ctr">
               <a:spcAft>
                 <a:spcPts val="0"/>
               </a:spcAft>
             </a:pPr>
             <a:r>
-              <a:rPr sz="1050" b="1">
+              <a:rPr sz="1100" b="1">
                 <a:solidFill>
                   <a:srgbClr val="1C1917"/>
                 </a:solidFill>
                 <a:latin typeface="Calibri"/>
               </a:rPr>
-              <a:t>Reward eligibility → admin-reviewed claim</a:t>
-            </a:r>
-          </a:p>
-        </p:txBody>
-      </p:sp>
-      <p:sp>
-        <p:nvSpPr>
-          <p:cNvPr id="25" name="Oval 24"/>
-          <p:cNvSpPr/>
-          <p:nvPr/>
-        </p:nvSpPr>
-        <p:spPr>
-          <a:xfrm>
-            <a:off x="6309359" y="4553712"/>
-            <a:ext cx="310896" cy="310896"/>
-          </a:xfrm>
-          <a:prstGeom prst="ellipse">
-            <a:avLst/>
-          </a:prstGeom>
-          <a:solidFill>
-            <a:srgbClr val="C81E1E"/>
-          </a:solidFill>
-          <a:ln>
-            <a:noFill/>
-          </a:ln>
-          <a:effectLst/>
-        </p:spPr>
-        <p:style>
-          <a:lnRef idx="1">
-            <a:schemeClr val="accent1"/>
-          </a:lnRef>
-          <a:fillRef idx="3">
-            <a:schemeClr val="accent1"/>
-          </a:fillRef>
-          <a:effectRef idx="2">
-            <a:schemeClr val="accent1"/>
-          </a:effectRef>
-          <a:fontRef idx="minor">
-            <a:schemeClr val="lt1"/>
-          </a:fontRef>
-        </p:style>
-        <p:txBody>
-          <a:bodyPr rtlCol="0" anchor="ctr" wrap="square" lIns="54864" rIns="54864" tIns="36576" bIns="36576"/>
-          <a:lstStyle/>
-          <a:p>
-            <a:pPr algn="ctr">
-              <a:spcAft>
-                <a:spcPts val="0"/>
-              </a:spcAft>
-            </a:pPr>
-            <a:r>
-              <a:rPr sz="1100" b="1">
-                <a:solidFill>
-                  <a:srgbClr val="FFFFFF"/>
-                </a:solidFill>
-                <a:latin typeface="Calibri"/>
-              </a:rPr>
-              <a:t>5</a:t>
-            </a:r>
-          </a:p>
-        </p:txBody>
-      </p:sp>
-      <p:sp>
-        <p:nvSpPr>
-          <p:cNvPr id="26" name="TextBox 25"/>
-          <p:cNvSpPr txBox="1"/>
-          <p:nvPr/>
-        </p:nvSpPr>
-        <p:spPr>
-          <a:xfrm>
-            <a:off x="6583680" y="5148072"/>
-            <a:ext cx="4937760" cy="731520"/>
-          </a:xfrm>
-          <a:prstGeom prst="rect">
-            <a:avLst/>
-          </a:prstGeom>
-          <a:noFill/>
-        </p:spPr>
-        <p:txBody>
-          <a:bodyPr wrap="square" anchor="t" lIns="0" rIns="0" tIns="0" bIns="0">
-            <a:spAutoFit/>
-          </a:bodyPr>
-          <a:lstStyle/>
-          <a:p>
-            <a:pPr algn="l">
-              <a:spcAft>
-                <a:spcPts val="0"/>
-              </a:spcAft>
-            </a:pPr>
-            <a:r>
-              <a:rPr sz="1050" b="1">
-                <a:solidFill>
-                  <a:srgbClr val="C81E1E"/>
-                </a:solidFill>
-                <a:latin typeface="Calibri"/>
-              </a:rPr>
-              <a:t>Protections: </a:t>
-            </a:r>
-            <a:r>
-              <a:rPr sz="1050" b="0">
-                <a:solidFill>
-                  <a:srgbClr val="57534E"/>
-                </a:solidFill>
-                <a:latin typeface="Calibri"/>
-              </a:rPr>
-              <a:t>8 tracked stages per referral · unique per-user codes · self-referral &amp; duplicate-device fraud checks · campaigns need admin approval notes</a:t>
-            </a:r>
-          </a:p>
-        </p:txBody>
-      </p:sp>
-      <p:sp>
-        <p:nvSpPr>
-          <p:cNvPr id="27" name="Rounded Rectangle 26"/>
-          <p:cNvSpPr/>
-          <p:nvPr/>
-        </p:nvSpPr>
-        <p:spPr>
-          <a:xfrm>
-            <a:off x="402336" y="6035040"/>
-            <a:ext cx="11384280" cy="457200"/>
-          </a:xfrm>
-          <a:prstGeom prst="roundRect">
-            <a:avLst/>
-          </a:prstGeom>
-          <a:solidFill>
-            <a:srgbClr val="FEF3C7"/>
-          </a:solidFill>
-          <a:ln w="12700">
-            <a:solidFill>
-              <a:srgbClr val="B45309"/>
-            </a:solidFill>
-          </a:ln>
-          <a:effectLst/>
-        </p:spPr>
-        <p:style>
-          <a:lnRef idx="1">
-            <a:schemeClr val="accent1"/>
-          </a:lnRef>
-          <a:fillRef idx="3">
-            <a:schemeClr val="accent1"/>
-          </a:fillRef>
-          <a:effectRef idx="2">
-            <a:schemeClr val="accent1"/>
-          </a:effectRef>
-          <a:fontRef idx="minor">
-            <a:schemeClr val="lt1"/>
-          </a:fontRef>
-        </p:style>
-        <p:txBody>
-          <a:bodyPr rtlCol="0" anchor="ctr" wrap="square" lIns="54864" rIns="54864" tIns="36576" bIns="36576"/>
-          <a:lstStyle/>
-          <a:p>
-            <a:pPr algn="ctr">
-              <a:spcAft>
-                <a:spcPts val="0"/>
-              </a:spcAft>
-            </a:pPr>
-            <a:r>
-              <a:rPr sz="1150" b="1">
-                <a:solidFill>
-                  <a:srgbClr val="B45309"/>
-                </a:solidFill>
-                <a:latin typeface="Calibri"/>
-              </a:rPr>
-              <a:t>Ethics by design: </a:t>
-            </a:r>
-            <a:r>
-              <a:rPr sz="1150" b="0">
+              <a:t>Deployed on free tiers - </a:t>
+            </a:r>
+            <a:r>
+              <a:rPr sz="1100" b="0">
                 <a:solidFill>
                   <a:srgbClr val="1C1917"/>
                 </a:solidFill>
                 <a:latin typeface="Calibri"/>
               </a:rPr>
-              <a:t>no cash equivalents, nothing tied to the act of donating, and every incentive is disclosed in the UI.</a:t>
+              <a:t>Cloudflare Pages (frontend) + Render + SQLite (backend). Live now, scan the QR on the last slide</a:t>
             </a:r>
           </a:p>
         </p:txBody>
@@ -8242,7 +7280,7 @@
                 </a:solidFill>
                 <a:latin typeface="Calibri"/>
               </a:rPr>
-              <a:t>UNDER THE HOOD</a:t>
+              <a:t>COMMUNITY ENGINE</a:t>
             </a:r>
           </a:p>
         </p:txBody>
@@ -8281,7 +7319,7 @@
                 </a:solidFill>
                 <a:latin typeface="Calibri"/>
               </a:rPr>
-              <a:t>Architecture, quality and how to try it</a:t>
+              <a:t>Rewards and referrals that keep donors engaged</a:t>
             </a:r>
           </a:p>
         </p:txBody>
@@ -8364,7 +7402,7 @@
                 </a:solidFill>
                 <a:latin typeface="Calibri"/>
               </a:rPr>
-              <a:t>BloodBridge - AI-assisted blood donor discovery</a:t>
+              <a:t>BloodBridge - AI-assisted blood donor discovery  ·  LIVE: https://bloodbridge-app.riteshnethi-art.workers.dev</a:t>
             </a:r>
           </a:p>
         </p:txBody>
@@ -8377,8 +7415,8 @@
         </p:nvSpPr>
         <p:spPr>
           <a:xfrm>
-            <a:off x="11247120" y="6473952"/>
-            <a:ext cx="548640" cy="274320"/>
+            <a:off x="10972800" y="6473952"/>
+            <a:ext cx="822960" cy="274320"/>
           </a:xfrm>
           <a:prstGeom prst="rect">
             <a:avLst/>
@@ -8403,7 +7441,7 @@
                 </a:solidFill>
                 <a:latin typeface="Calibri"/>
               </a:rPr>
-              <a:t>6 / 6</a:t>
+              <a:t>6 / 7</a:t>
             </a:r>
           </a:p>
         </p:txBody>
@@ -8416,12 +7454,12 @@
         </p:nvSpPr>
         <p:spPr>
           <a:xfrm>
-            <a:off x="591159" y="1517904"/>
-            <a:ext cx="3291840" cy="1225296"/>
+            <a:off x="402336" y="1572768"/>
+            <a:ext cx="5486400" cy="4315968"/>
           </a:xfrm>
           <a:prstGeom prst="roundRect">
             <a:avLst>
-              <a:gd name="adj" fmla="val 10000"/>
+              <a:gd name="adj" fmla="val 6000"/>
             </a:avLst>
           </a:prstGeom>
           <a:solidFill>
@@ -8449,59 +7487,31 @@
           </a:fontRef>
         </p:style>
         <p:txBody>
-          <a:bodyPr rtlCol="0" anchor="ctr" wrap="square" lIns="73152" rIns="73152" tIns="18288" bIns="18288"/>
-          <a:lstStyle/>
-          <a:p>
-            <a:pPr algn="ctr">
-              <a:spcAft>
-                <a:spcPts val="300"/>
-              </a:spcAft>
-            </a:pPr>
-            <a:r>
-              <a:rPr sz="1250" b="1">
-                <a:solidFill>
-                  <a:srgbClr val="1C1917"/>
-                </a:solidFill>
-                <a:latin typeface="Calibri"/>
-              </a:rPr>
-              <a:t>Frontend</a:t>
-            </a:r>
-          </a:p>
-          <a:p>
-            <a:pPr algn="ctr">
-              <a:spcAft>
-                <a:spcPts val="0"/>
-              </a:spcAft>
-            </a:pPr>
-            <a:r>
-              <a:rPr sz="950" b="0">
-                <a:solidFill>
-                  <a:srgbClr val="57534E"/>
-                </a:solidFill>
-                <a:latin typeface="Calibri"/>
-              </a:rPr>
-              <a:t>React 18 · TypeScript · Vite · Tailwind
-12 pages, protected routes, notification bell</a:t>
-            </a:r>
-          </a:p>
-        </p:txBody>
-      </p:sp>
-      <p:sp>
-        <p:nvSpPr>
-          <p:cNvPr id="8" name="Oval 7"/>
+          <a:bodyPr rtlCol="0" anchor="ctr"/>
+          <a:lstStyle/>
+          <a:p>
+            <a:pPr algn="ctr"/>
+          </a:p>
+        </p:txBody>
+      </p:sp>
+      <p:sp>
+        <p:nvSpPr>
+          <p:cNvPr id="8" name="Rounded Rectangle 7"/>
           <p:cNvSpPr/>
           <p:nvPr/>
         </p:nvSpPr>
         <p:spPr>
           <a:xfrm>
-            <a:off x="472287" y="1399031"/>
-            <a:ext cx="329184" cy="329184"/>
-          </a:xfrm>
-          <a:prstGeom prst="ellipse">
-            <a:avLst/>
+            <a:off x="402336" y="1572768"/>
+            <a:ext cx="5486400" cy="502920"/>
+          </a:xfrm>
+          <a:prstGeom prst="roundRect">
+            <a:avLst>
+              <a:gd name="adj" fmla="val 6000"/>
+            </a:avLst>
           </a:prstGeom>
           <a:solidFill>
-            <a:srgbClr val="C81E1E"/>
+            <a:srgbClr val="15803D"/>
           </a:solidFill>
           <a:ln>
             <a:noFill/>
@@ -8523,63 +7533,185 @@
           </a:fontRef>
         </p:style>
         <p:txBody>
-          <a:bodyPr rtlCol="0" anchor="ctr" wrap="square" lIns="54864" rIns="54864" tIns="36576" bIns="36576"/>
-          <a:lstStyle/>
-          <a:p>
-            <a:pPr algn="ctr">
+          <a:bodyPr rtlCol="0" anchor="ctr" wrap="square" lIns="228600" tIns="0" bIns="0"/>
+          <a:lstStyle/>
+          <a:p>
+            <a:pPr algn="l">
               <a:spcAft>
                 <a:spcPts val="0"/>
               </a:spcAft>
             </a:pPr>
             <a:r>
-              <a:rPr sz="1300" b="1">
+              <a:rPr sz="1350" b="1">
                 <a:solidFill>
                   <a:srgbClr val="FFFFFF"/>
                 </a:solidFill>
                 <a:latin typeface="Calibri"/>
               </a:rPr>
-              <a:t>1</a:t>
-            </a:r>
-          </a:p>
-        </p:txBody>
-      </p:sp>
-      <p:cxnSp>
-        <p:nvCxnSpPr>
-          <p:cNvPr id="9" name="Connector 8"/>
-          <p:cNvCxnSpPr/>
-          <p:nvPr/>
-        </p:nvCxnSpPr>
-        <p:spPr>
-          <a:xfrm>
-            <a:off x="3937863" y="2130552"/>
-            <a:ext cx="457200" cy="0"/>
-          </a:xfrm>
-          <a:prstGeom prst="line">
+              <a:t>COMMUNITY REWARDS</a:t>
+            </a:r>
+          </a:p>
+        </p:txBody>
+      </p:sp>
+      <p:sp>
+        <p:nvSpPr>
+          <p:cNvPr id="9" name="TextBox 8"/>
+          <p:cNvSpPr txBox="1"/>
+          <p:nvPr/>
+        </p:nvSpPr>
+        <p:spPr>
+          <a:xfrm>
+            <a:off x="685800" y="2258568"/>
+            <a:ext cx="4983480" cy="3493008"/>
+          </a:xfrm>
+          <a:prstGeom prst="rect">
             <a:avLst/>
           </a:prstGeom>
-          <a:ln w="22225">
-            <a:solidFill>
-              <a:srgbClr val="57534E"/>
-            </a:solidFill>
-            <a:tailEnd type="triangle" w="med" len="med"/>
-          </a:ln>
-          <a:effectLst/>
-        </p:spPr>
-        <p:style>
-          <a:lnRef idx="2">
-            <a:schemeClr val="accent1"/>
-          </a:lnRef>
-          <a:fillRef idx="0">
-            <a:schemeClr val="accent1"/>
-          </a:fillRef>
-          <a:effectRef idx="1">
-            <a:schemeClr val="accent1"/>
-          </a:effectRef>
-          <a:fontRef idx="minor">
-            <a:schemeClr val="tx1"/>
-          </a:fontRef>
-        </p:style>
-      </p:cxnSp>
+          <a:noFill/>
+        </p:spPr>
+        <p:txBody>
+          <a:bodyPr wrap="square" anchor="t" lIns="0" rIns="0" tIns="0" bIns="0">
+            <a:spAutoFit/>
+          </a:bodyPr>
+          <a:lstStyle/>
+          <a:p>
+            <a:pPr algn="l">
+              <a:spcAft>
+                <a:spcPts val="900"/>
+              </a:spcAft>
+            </a:pPr>
+            <a:r>
+              <a:rPr sz="1200" b="1">
+                <a:solidFill>
+                  <a:srgbClr val="C81E1E"/>
+                </a:solidFill>
+                <a:latin typeface="Calibri"/>
+              </a:rPr>
+              <a:t>•  </a:t>
+            </a:r>
+            <a:r>
+              <a:rPr sz="1200" b="1">
+                <a:solidFill>
+                  <a:srgbClr val="1C1917"/>
+                </a:solidFill>
+                <a:latin typeface="Calibri"/>
+              </a:rPr>
+              <a:t>Earn recognition: </a:t>
+            </a:r>
+            <a:r>
+              <a:rPr sz="1200" b="0">
+                <a:solidFill>
+                  <a:srgbClr val="1C1917"/>
+                </a:solidFill>
+                <a:latin typeface="Calibri"/>
+              </a:rPr>
+              <a:t>badges and certificates for completing your profile, inviting friends and learning donation facts</a:t>
+            </a:r>
+          </a:p>
+          <a:p>
+            <a:pPr algn="l">
+              <a:spcAft>
+                <a:spcPts val="900"/>
+              </a:spcAft>
+            </a:pPr>
+            <a:r>
+              <a:rPr sz="1200" b="1">
+                <a:solidFill>
+                  <a:srgbClr val="C81E1E"/>
+                </a:solidFill>
+                <a:latin typeface="Calibri"/>
+              </a:rPr>
+              <a:t>•  </a:t>
+            </a:r>
+            <a:r>
+              <a:rPr sz="1200" b="1">
+                <a:solidFill>
+                  <a:srgbClr val="1C1917"/>
+                </a:solidFill>
+                <a:latin typeface="Calibri"/>
+              </a:rPr>
+              <a:t>Redeem: </a:t>
+            </a:r>
+            <a:r>
+              <a:rPr sz="1200" b="0">
+                <a:solidFill>
+                  <a:srgbClr val="1C1917"/>
+                </a:solidFill>
+                <a:latin typeface="Calibri"/>
+              </a:rPr>
+              <a:t>for partner offers from verified local partners - always labeled “Demo Partner” in the demo</a:t>
+            </a:r>
+          </a:p>
+          <a:p>
+            <a:pPr algn="l">
+              <a:spcAft>
+                <a:spcPts val="900"/>
+              </a:spcAft>
+            </a:pPr>
+            <a:r>
+              <a:rPr sz="1200" b="1">
+                <a:solidFill>
+                  <a:srgbClr val="C81E1E"/>
+                </a:solidFill>
+                <a:latin typeface="Calibri"/>
+              </a:rPr>
+              <a:t>•  </a:t>
+            </a:r>
+            <a:r>
+              <a:rPr sz="1200" b="1">
+                <a:solidFill>
+                  <a:srgbClr val="1C1917"/>
+                </a:solidFill>
+                <a:latin typeface="Calibri"/>
+              </a:rPr>
+              <a:t>Transactional claims: </a:t>
+            </a:r>
+            <a:r>
+              <a:rPr sz="1200" b="0">
+                <a:solidFill>
+                  <a:srgbClr val="1C1917"/>
+                </a:solidFill>
+                <a:latin typeface="Calibri"/>
+              </a:rPr>
+              <a:t>reserve → verify → redeem; every step is audited and race-safe</a:t>
+            </a:r>
+          </a:p>
+          <a:p>
+            <a:pPr algn="l">
+              <a:spcAft>
+                <a:spcPts val="900"/>
+              </a:spcAft>
+            </a:pPr>
+            <a:r>
+              <a:rPr sz="1200" b="1">
+                <a:solidFill>
+                  <a:srgbClr val="C81E1E"/>
+                </a:solidFill>
+                <a:latin typeface="Calibri"/>
+              </a:rPr>
+              <a:t>•  </a:t>
+            </a:r>
+            <a:r>
+              <a:rPr sz="1200" b="1">
+                <a:solidFill>
+                  <a:srgbClr val="1C1917"/>
+                </a:solidFill>
+                <a:latin typeface="Calibri"/>
+              </a:rPr>
+              <a:t>Never cash: </a:t>
+            </a:r>
+            <a:r>
+              <a:rPr sz="1200" b="0">
+                <a:solidFill>
+                  <a:srgbClr val="1C1917"/>
+                </a:solidFill>
+                <a:latin typeface="Calibri"/>
+              </a:rPr>
+              <a:t>no money, no gift cards, and nothing is ever tied to donating blood - recognition only</a:t>
+            </a:r>
+          </a:p>
+        </p:txBody>
+      </p:sp>
       <p:sp>
         <p:nvSpPr>
           <p:cNvPr id="10" name="Rounded Rectangle 9"/>
@@ -8588,12 +7720,12 @@
         </p:nvSpPr>
         <p:spPr>
           <a:xfrm>
-            <a:off x="4449927" y="1517904"/>
-            <a:ext cx="3291840" cy="1225296"/>
+            <a:off x="6300216" y="1572768"/>
+            <a:ext cx="5486400" cy="4315968"/>
           </a:xfrm>
           <a:prstGeom prst="roundRect">
             <a:avLst>
-              <a:gd name="adj" fmla="val 10000"/>
+              <a:gd name="adj" fmla="val 6000"/>
             </a:avLst>
           </a:prstGeom>
           <a:solidFill>
@@ -8621,56 +7753,28 @@
           </a:fontRef>
         </p:style>
         <p:txBody>
-          <a:bodyPr rtlCol="0" anchor="ctr" wrap="square" lIns="73152" rIns="73152" tIns="18288" bIns="18288"/>
-          <a:lstStyle/>
-          <a:p>
-            <a:pPr algn="ctr">
-              <a:spcAft>
-                <a:spcPts val="300"/>
-              </a:spcAft>
-            </a:pPr>
-            <a:r>
-              <a:rPr sz="1250" b="1">
-                <a:solidFill>
-                  <a:srgbClr val="1C1917"/>
-                </a:solidFill>
-                <a:latin typeface="Calibri"/>
-              </a:rPr>
-              <a:t>API</a:t>
-            </a:r>
-          </a:p>
-          <a:p>
-            <a:pPr algn="ctr">
-              <a:spcAft>
-                <a:spcPts val="0"/>
-              </a:spcAft>
-            </a:pPr>
-            <a:r>
-              <a:rPr sz="950" b="0">
-                <a:solidFill>
-                  <a:srgbClr val="57534E"/>
-                </a:solidFill>
-                <a:latin typeface="Calibri"/>
-              </a:rPr>
-              <a:t>FastAPI · Pydantic schemas
-9 routers, role-based auth (PBKDF2 + HMAC tokens)</a:t>
-            </a:r>
-          </a:p>
-        </p:txBody>
-      </p:sp>
-      <p:sp>
-        <p:nvSpPr>
-          <p:cNvPr id="11" name="Oval 10"/>
+          <a:bodyPr rtlCol="0" anchor="ctr"/>
+          <a:lstStyle/>
+          <a:p>
+            <a:pPr algn="ctr"/>
+          </a:p>
+        </p:txBody>
+      </p:sp>
+      <p:sp>
+        <p:nvSpPr>
+          <p:cNvPr id="11" name="Rounded Rectangle 10"/>
           <p:cNvSpPr/>
           <p:nvPr/>
         </p:nvSpPr>
         <p:spPr>
           <a:xfrm>
-            <a:off x="4331055" y="1399031"/>
-            <a:ext cx="329184" cy="329184"/>
-          </a:xfrm>
-          <a:prstGeom prst="ellipse">
-            <a:avLst/>
+            <a:off x="6300216" y="1572768"/>
+            <a:ext cx="5486400" cy="502920"/>
+          </a:xfrm>
+          <a:prstGeom prst="roundRect">
+            <a:avLst>
+              <a:gd name="adj" fmla="val 6000"/>
+            </a:avLst>
           </a:prstGeom>
           <a:solidFill>
             <a:srgbClr val="C81E1E"/>
@@ -8695,6 +7799,124 @@
           </a:fontRef>
         </p:style>
         <p:txBody>
+          <a:bodyPr rtlCol="0" anchor="ctr" wrap="square" lIns="228600" tIns="0" bIns="0"/>
+          <a:lstStyle/>
+          <a:p>
+            <a:pPr algn="l">
+              <a:spcAft>
+                <a:spcPts val="0"/>
+              </a:spcAft>
+            </a:pPr>
+            <a:r>
+              <a:rPr sz="1350" b="1">
+                <a:solidFill>
+                  <a:srgbClr val="FFFFFF"/>
+                </a:solidFill>
+                <a:latin typeface="Calibri"/>
+              </a:rPr>
+              <a:t>REFERRAL PROGRAM - TRACKED FUNNEL</a:t>
+            </a:r>
+          </a:p>
+        </p:txBody>
+      </p:sp>
+      <p:sp>
+        <p:nvSpPr>
+          <p:cNvPr id="12" name="Rounded Rectangle 11"/>
+          <p:cNvSpPr/>
+          <p:nvPr/>
+        </p:nvSpPr>
+        <p:spPr>
+          <a:xfrm>
+            <a:off x="6528816" y="2194560"/>
+            <a:ext cx="3291840" cy="420624"/>
+          </a:xfrm>
+          <a:prstGeom prst="roundRect">
+            <a:avLst>
+              <a:gd name="adj" fmla="val 22000"/>
+            </a:avLst>
+          </a:prstGeom>
+          <a:solidFill>
+            <a:srgbClr val="FAFAF9"/>
+          </a:solidFill>
+          <a:ln w="12700">
+            <a:solidFill>
+              <a:srgbClr val="E7E5E4"/>
+            </a:solidFill>
+          </a:ln>
+          <a:effectLst/>
+        </p:spPr>
+        <p:style>
+          <a:lnRef idx="1">
+            <a:schemeClr val="accent1"/>
+          </a:lnRef>
+          <a:fillRef idx="3">
+            <a:schemeClr val="accent1"/>
+          </a:fillRef>
+          <a:effectRef idx="2">
+            <a:schemeClr val="accent1"/>
+          </a:effectRef>
+          <a:fontRef idx="minor">
+            <a:schemeClr val="lt1"/>
+          </a:fontRef>
+        </p:style>
+        <p:txBody>
+          <a:bodyPr rtlCol="0" anchor="ctr" wrap="square" lIns="128016" rIns="54864" tIns="0" bIns="0"/>
+          <a:lstStyle/>
+          <a:p>
+            <a:pPr algn="l">
+              <a:spcAft>
+                <a:spcPts val="0"/>
+              </a:spcAft>
+            </a:pPr>
+            <a:r>
+              <a:rPr sz="1050" b="0">
+                <a:solidFill>
+                  <a:srgbClr val="1C1917"/>
+                </a:solidFill>
+                <a:latin typeface="Calibri"/>
+              </a:rPr>
+              <a:t>Share link  BLOODBRIDGE-XXXXX</a:t>
+            </a:r>
+          </a:p>
+        </p:txBody>
+      </p:sp>
+      <p:sp>
+        <p:nvSpPr>
+          <p:cNvPr id="13" name="Oval 12"/>
+          <p:cNvSpPr/>
+          <p:nvPr/>
+        </p:nvSpPr>
+        <p:spPr>
+          <a:xfrm>
+            <a:off x="6309359" y="2249424"/>
+            <a:ext cx="310896" cy="310896"/>
+          </a:xfrm>
+          <a:prstGeom prst="ellipse">
+            <a:avLst/>
+          </a:prstGeom>
+          <a:solidFill>
+            <a:srgbClr val="C81E1E"/>
+          </a:solidFill>
+          <a:ln>
+            <a:noFill/>
+          </a:ln>
+          <a:effectLst/>
+        </p:spPr>
+        <p:style>
+          <a:lnRef idx="1">
+            <a:schemeClr val="accent1"/>
+          </a:lnRef>
+          <a:fillRef idx="3">
+            <a:schemeClr val="accent1"/>
+          </a:fillRef>
+          <a:effectRef idx="2">
+            <a:schemeClr val="accent1"/>
+          </a:effectRef>
+          <a:fontRef idx="minor">
+            <a:schemeClr val="lt1"/>
+          </a:fontRef>
+        </p:style>
+        <p:txBody>
           <a:bodyPr rtlCol="0" anchor="ctr" wrap="square" lIns="54864" rIns="54864" tIns="36576" bIns="36576"/>
           <a:lstStyle/>
           <a:p>
@@ -8704,34 +7926,34 @@
               </a:spcAft>
             </a:pPr>
             <a:r>
-              <a:rPr sz="1300" b="1">
+              <a:rPr sz="1100" b="1">
                 <a:solidFill>
                   <a:srgbClr val="FFFFFF"/>
                 </a:solidFill>
                 <a:latin typeface="Calibri"/>
               </a:rPr>
-              <a:t>2</a:t>
+              <a:t>1</a:t>
             </a:r>
           </a:p>
         </p:txBody>
       </p:sp>
       <p:cxnSp>
         <p:nvCxnSpPr>
-          <p:cNvPr id="12" name="Connector 11"/>
+          <p:cNvPr id="14" name="Connector 13"/>
           <p:cNvCxnSpPr/>
           <p:nvPr/>
         </p:nvCxnSpPr>
         <p:spPr>
           <a:xfrm>
-            <a:off x="7796631" y="2130552"/>
-            <a:ext cx="457200" cy="0"/>
+            <a:off x="8174736" y="2624327"/>
+            <a:ext cx="0" cy="128017"/>
           </a:xfrm>
           <a:prstGeom prst="line">
             <a:avLst/>
           </a:prstGeom>
-          <a:ln w="22225">
+          <a:ln w="19050">
             <a:solidFill>
-              <a:srgbClr val="57534E"/>
+              <a:srgbClr val="C81E1E"/>
             </a:solidFill>
             <a:tailEnd type="triangle" w="med" len="med"/>
           </a:ln>
@@ -8754,14 +7976,931 @@
       </p:cxnSp>
       <p:sp>
         <p:nvSpPr>
-          <p:cNvPr id="13" name="Rounded Rectangle 12"/>
+          <p:cNvPr id="15" name="Rounded Rectangle 14"/>
           <p:cNvSpPr/>
           <p:nvPr/>
         </p:nvSpPr>
         <p:spPr>
           <a:xfrm>
-            <a:off x="8308695" y="1517904"/>
-            <a:ext cx="3291840" cy="1225296"/>
+            <a:off x="6528816" y="2770632"/>
+            <a:ext cx="3291840" cy="420624"/>
+          </a:xfrm>
+          <a:prstGeom prst="roundRect">
+            <a:avLst>
+              <a:gd name="adj" fmla="val 22000"/>
+            </a:avLst>
+          </a:prstGeom>
+          <a:solidFill>
+            <a:srgbClr val="FAFAF9"/>
+          </a:solidFill>
+          <a:ln w="12700">
+            <a:solidFill>
+              <a:srgbClr val="E7E5E4"/>
+            </a:solidFill>
+          </a:ln>
+          <a:effectLst/>
+        </p:spPr>
+        <p:style>
+          <a:lnRef idx="1">
+            <a:schemeClr val="accent1"/>
+          </a:lnRef>
+          <a:fillRef idx="3">
+            <a:schemeClr val="accent1"/>
+          </a:fillRef>
+          <a:effectRef idx="2">
+            <a:schemeClr val="accent1"/>
+          </a:effectRef>
+          <a:fontRef idx="minor">
+            <a:schemeClr val="lt1"/>
+          </a:fontRef>
+        </p:style>
+        <p:txBody>
+          <a:bodyPr rtlCol="0" anchor="ctr" wrap="square" lIns="128016" rIns="54864" tIns="0" bIns="0"/>
+          <a:lstStyle/>
+          <a:p>
+            <a:pPr algn="l">
+              <a:spcAft>
+                <a:spcPts val="0"/>
+              </a:spcAft>
+            </a:pPr>
+            <a:r>
+              <a:rPr sz="1050" b="0">
+                <a:solidFill>
+                  <a:srgbClr val="1C1917"/>
+                </a:solidFill>
+                <a:latin typeface="Calibri"/>
+              </a:rPr>
+              <a:t>Friend opens &amp; registers</a:t>
+            </a:r>
+          </a:p>
+        </p:txBody>
+      </p:sp>
+      <p:sp>
+        <p:nvSpPr>
+          <p:cNvPr id="16" name="Oval 15"/>
+          <p:cNvSpPr/>
+          <p:nvPr/>
+        </p:nvSpPr>
+        <p:spPr>
+          <a:xfrm>
+            <a:off x="6309359" y="2825496"/>
+            <a:ext cx="310896" cy="310896"/>
+          </a:xfrm>
+          <a:prstGeom prst="ellipse">
+            <a:avLst/>
+          </a:prstGeom>
+          <a:solidFill>
+            <a:srgbClr val="C81E1E"/>
+          </a:solidFill>
+          <a:ln>
+            <a:noFill/>
+          </a:ln>
+          <a:effectLst/>
+        </p:spPr>
+        <p:style>
+          <a:lnRef idx="1">
+            <a:schemeClr val="accent1"/>
+          </a:lnRef>
+          <a:fillRef idx="3">
+            <a:schemeClr val="accent1"/>
+          </a:fillRef>
+          <a:effectRef idx="2">
+            <a:schemeClr val="accent1"/>
+          </a:effectRef>
+          <a:fontRef idx="minor">
+            <a:schemeClr val="lt1"/>
+          </a:fontRef>
+        </p:style>
+        <p:txBody>
+          <a:bodyPr rtlCol="0" anchor="ctr" wrap="square" lIns="54864" rIns="54864" tIns="36576" bIns="36576"/>
+          <a:lstStyle/>
+          <a:p>
+            <a:pPr algn="ctr">
+              <a:spcAft>
+                <a:spcPts val="0"/>
+              </a:spcAft>
+            </a:pPr>
+            <a:r>
+              <a:rPr sz="1100" b="1">
+                <a:solidFill>
+                  <a:srgbClr val="FFFFFF"/>
+                </a:solidFill>
+                <a:latin typeface="Calibri"/>
+              </a:rPr>
+              <a:t>2</a:t>
+            </a:r>
+          </a:p>
+        </p:txBody>
+      </p:sp>
+      <p:cxnSp>
+        <p:nvCxnSpPr>
+          <p:cNvPr id="17" name="Connector 16"/>
+          <p:cNvCxnSpPr/>
+          <p:nvPr/>
+        </p:nvCxnSpPr>
+        <p:spPr>
+          <a:xfrm>
+            <a:off x="8174736" y="3200399"/>
+            <a:ext cx="0" cy="128016"/>
+          </a:xfrm>
+          <a:prstGeom prst="line">
+            <a:avLst/>
+          </a:prstGeom>
+          <a:ln w="19050">
+            <a:solidFill>
+              <a:srgbClr val="C81E1E"/>
+            </a:solidFill>
+            <a:tailEnd type="triangle" w="med" len="med"/>
+          </a:ln>
+          <a:effectLst/>
+        </p:spPr>
+        <p:style>
+          <a:lnRef idx="2">
+            <a:schemeClr val="accent1"/>
+          </a:lnRef>
+          <a:fillRef idx="0">
+            <a:schemeClr val="accent1"/>
+          </a:fillRef>
+          <a:effectRef idx="1">
+            <a:schemeClr val="accent1"/>
+          </a:effectRef>
+          <a:fontRef idx="minor">
+            <a:schemeClr val="tx1"/>
+          </a:fontRef>
+        </p:style>
+      </p:cxnSp>
+      <p:sp>
+        <p:nvSpPr>
+          <p:cNvPr id="18" name="Rounded Rectangle 17"/>
+          <p:cNvSpPr/>
+          <p:nvPr/>
+        </p:nvSpPr>
+        <p:spPr>
+          <a:xfrm>
+            <a:off x="6528816" y="3346703"/>
+            <a:ext cx="3291840" cy="420624"/>
+          </a:xfrm>
+          <a:prstGeom prst="roundRect">
+            <a:avLst>
+              <a:gd name="adj" fmla="val 22000"/>
+            </a:avLst>
+          </a:prstGeom>
+          <a:solidFill>
+            <a:srgbClr val="FAFAF9"/>
+          </a:solidFill>
+          <a:ln w="12700">
+            <a:solidFill>
+              <a:srgbClr val="E7E5E4"/>
+            </a:solidFill>
+          </a:ln>
+          <a:effectLst/>
+        </p:spPr>
+        <p:style>
+          <a:lnRef idx="1">
+            <a:schemeClr val="accent1"/>
+          </a:lnRef>
+          <a:fillRef idx="3">
+            <a:schemeClr val="accent1"/>
+          </a:fillRef>
+          <a:effectRef idx="2">
+            <a:schemeClr val="accent1"/>
+          </a:effectRef>
+          <a:fontRef idx="minor">
+            <a:schemeClr val="lt1"/>
+          </a:fontRef>
+        </p:style>
+        <p:txBody>
+          <a:bodyPr rtlCol="0" anchor="ctr" wrap="square" lIns="128016" rIns="54864" tIns="0" bIns="0"/>
+          <a:lstStyle/>
+          <a:p>
+            <a:pPr algn="l">
+              <a:spcAft>
+                <a:spcPts val="0"/>
+              </a:spcAft>
+            </a:pPr>
+            <a:r>
+              <a:rPr sz="1050" b="0">
+                <a:solidFill>
+                  <a:srgbClr val="1C1917"/>
+                </a:solidFill>
+                <a:latin typeface="Calibri"/>
+              </a:rPr>
+              <a:t>Profile completed</a:t>
+            </a:r>
+          </a:p>
+        </p:txBody>
+      </p:sp>
+      <p:sp>
+        <p:nvSpPr>
+          <p:cNvPr id="19" name="Oval 18"/>
+          <p:cNvSpPr/>
+          <p:nvPr/>
+        </p:nvSpPr>
+        <p:spPr>
+          <a:xfrm>
+            <a:off x="6309359" y="3401568"/>
+            <a:ext cx="310896" cy="310896"/>
+          </a:xfrm>
+          <a:prstGeom prst="ellipse">
+            <a:avLst/>
+          </a:prstGeom>
+          <a:solidFill>
+            <a:srgbClr val="C81E1E"/>
+          </a:solidFill>
+          <a:ln>
+            <a:noFill/>
+          </a:ln>
+          <a:effectLst/>
+        </p:spPr>
+        <p:style>
+          <a:lnRef idx="1">
+            <a:schemeClr val="accent1"/>
+          </a:lnRef>
+          <a:fillRef idx="3">
+            <a:schemeClr val="accent1"/>
+          </a:fillRef>
+          <a:effectRef idx="2">
+            <a:schemeClr val="accent1"/>
+          </a:effectRef>
+          <a:fontRef idx="minor">
+            <a:schemeClr val="lt1"/>
+          </a:fontRef>
+        </p:style>
+        <p:txBody>
+          <a:bodyPr rtlCol="0" anchor="ctr" wrap="square" lIns="54864" rIns="54864" tIns="36576" bIns="36576"/>
+          <a:lstStyle/>
+          <a:p>
+            <a:pPr algn="ctr">
+              <a:spcAft>
+                <a:spcPts val="0"/>
+              </a:spcAft>
+            </a:pPr>
+            <a:r>
+              <a:rPr sz="1100" b="1">
+                <a:solidFill>
+                  <a:srgbClr val="FFFFFF"/>
+                </a:solidFill>
+                <a:latin typeface="Calibri"/>
+              </a:rPr>
+              <a:t>3</a:t>
+            </a:r>
+          </a:p>
+        </p:txBody>
+      </p:sp>
+      <p:cxnSp>
+        <p:nvCxnSpPr>
+          <p:cNvPr id="20" name="Connector 19"/>
+          <p:cNvCxnSpPr/>
+          <p:nvPr/>
+        </p:nvCxnSpPr>
+        <p:spPr>
+          <a:xfrm>
+            <a:off x="8174736" y="3776472"/>
+            <a:ext cx="0" cy="128016"/>
+          </a:xfrm>
+          <a:prstGeom prst="line">
+            <a:avLst/>
+          </a:prstGeom>
+          <a:ln w="19050">
+            <a:solidFill>
+              <a:srgbClr val="C81E1E"/>
+            </a:solidFill>
+            <a:tailEnd type="triangle" w="med" len="med"/>
+          </a:ln>
+          <a:effectLst/>
+        </p:spPr>
+        <p:style>
+          <a:lnRef idx="2">
+            <a:schemeClr val="accent1"/>
+          </a:lnRef>
+          <a:fillRef idx="0">
+            <a:schemeClr val="accent1"/>
+          </a:fillRef>
+          <a:effectRef idx="1">
+            <a:schemeClr val="accent1"/>
+          </a:effectRef>
+          <a:fontRef idx="minor">
+            <a:schemeClr val="tx1"/>
+          </a:fontRef>
+        </p:style>
+      </p:cxnSp>
+      <p:sp>
+        <p:nvSpPr>
+          <p:cNvPr id="21" name="Rounded Rectangle 20"/>
+          <p:cNvSpPr/>
+          <p:nvPr/>
+        </p:nvSpPr>
+        <p:spPr>
+          <a:xfrm>
+            <a:off x="6528816" y="3922776"/>
+            <a:ext cx="3291840" cy="420624"/>
+          </a:xfrm>
+          <a:prstGeom prst="roundRect">
+            <a:avLst>
+              <a:gd name="adj" fmla="val 22000"/>
+            </a:avLst>
+          </a:prstGeom>
+          <a:solidFill>
+            <a:srgbClr val="FAFAF9"/>
+          </a:solidFill>
+          <a:ln w="12700">
+            <a:solidFill>
+              <a:srgbClr val="E7E5E4"/>
+            </a:solidFill>
+          </a:ln>
+          <a:effectLst/>
+        </p:spPr>
+        <p:style>
+          <a:lnRef idx="1">
+            <a:schemeClr val="accent1"/>
+          </a:lnRef>
+          <a:fillRef idx="3">
+            <a:schemeClr val="accent1"/>
+          </a:fillRef>
+          <a:effectRef idx="2">
+            <a:schemeClr val="accent1"/>
+          </a:effectRef>
+          <a:fontRef idx="minor">
+            <a:schemeClr val="lt1"/>
+          </a:fontRef>
+        </p:style>
+        <p:txBody>
+          <a:bodyPr rtlCol="0" anchor="ctr" wrap="square" lIns="128016" rIns="54864" tIns="0" bIns="0"/>
+          <a:lstStyle/>
+          <a:p>
+            <a:pPr algn="l">
+              <a:spcAft>
+                <a:spcPts val="0"/>
+              </a:spcAft>
+            </a:pPr>
+            <a:r>
+              <a:rPr sz="1050" b="0">
+                <a:solidFill>
+                  <a:srgbClr val="1C1917"/>
+                </a:solidFill>
+                <a:latin typeface="Calibri"/>
+              </a:rPr>
+              <a:t>First request or donor response</a:t>
+            </a:r>
+          </a:p>
+        </p:txBody>
+      </p:sp>
+      <p:sp>
+        <p:nvSpPr>
+          <p:cNvPr id="22" name="Oval 21"/>
+          <p:cNvSpPr/>
+          <p:nvPr/>
+        </p:nvSpPr>
+        <p:spPr>
+          <a:xfrm>
+            <a:off x="6309359" y="3977639"/>
+            <a:ext cx="310896" cy="310896"/>
+          </a:xfrm>
+          <a:prstGeom prst="ellipse">
+            <a:avLst/>
+          </a:prstGeom>
+          <a:solidFill>
+            <a:srgbClr val="C81E1E"/>
+          </a:solidFill>
+          <a:ln>
+            <a:noFill/>
+          </a:ln>
+          <a:effectLst/>
+        </p:spPr>
+        <p:style>
+          <a:lnRef idx="1">
+            <a:schemeClr val="accent1"/>
+          </a:lnRef>
+          <a:fillRef idx="3">
+            <a:schemeClr val="accent1"/>
+          </a:fillRef>
+          <a:effectRef idx="2">
+            <a:schemeClr val="accent1"/>
+          </a:effectRef>
+          <a:fontRef idx="minor">
+            <a:schemeClr val="lt1"/>
+          </a:fontRef>
+        </p:style>
+        <p:txBody>
+          <a:bodyPr rtlCol="0" anchor="ctr" wrap="square" lIns="54864" rIns="54864" tIns="36576" bIns="36576"/>
+          <a:lstStyle/>
+          <a:p>
+            <a:pPr algn="ctr">
+              <a:spcAft>
+                <a:spcPts val="0"/>
+              </a:spcAft>
+            </a:pPr>
+            <a:r>
+              <a:rPr sz="1100" b="1">
+                <a:solidFill>
+                  <a:srgbClr val="FFFFFF"/>
+                </a:solidFill>
+                <a:latin typeface="Calibri"/>
+              </a:rPr>
+              <a:t>4</a:t>
+            </a:r>
+          </a:p>
+        </p:txBody>
+      </p:sp>
+      <p:cxnSp>
+        <p:nvCxnSpPr>
+          <p:cNvPr id="23" name="Connector 22"/>
+          <p:cNvCxnSpPr/>
+          <p:nvPr/>
+        </p:nvCxnSpPr>
+        <p:spPr>
+          <a:xfrm>
+            <a:off x="8174736" y="4352544"/>
+            <a:ext cx="0" cy="128016"/>
+          </a:xfrm>
+          <a:prstGeom prst="line">
+            <a:avLst/>
+          </a:prstGeom>
+          <a:ln w="19050">
+            <a:solidFill>
+              <a:srgbClr val="C81E1E"/>
+            </a:solidFill>
+            <a:tailEnd type="triangle" w="med" len="med"/>
+          </a:ln>
+          <a:effectLst/>
+        </p:spPr>
+        <p:style>
+          <a:lnRef idx="2">
+            <a:schemeClr val="accent1"/>
+          </a:lnRef>
+          <a:fillRef idx="0">
+            <a:schemeClr val="accent1"/>
+          </a:fillRef>
+          <a:effectRef idx="1">
+            <a:schemeClr val="accent1"/>
+          </a:effectRef>
+          <a:fontRef idx="minor">
+            <a:schemeClr val="tx1"/>
+          </a:fontRef>
+        </p:style>
+      </p:cxnSp>
+      <p:sp>
+        <p:nvSpPr>
+          <p:cNvPr id="24" name="Rounded Rectangle 23"/>
+          <p:cNvSpPr/>
+          <p:nvPr/>
+        </p:nvSpPr>
+        <p:spPr>
+          <a:xfrm>
+            <a:off x="6528816" y="4498848"/>
+            <a:ext cx="3291840" cy="420624"/>
+          </a:xfrm>
+          <a:prstGeom prst="roundRect">
+            <a:avLst>
+              <a:gd name="adj" fmla="val 22000"/>
+            </a:avLst>
+          </a:prstGeom>
+          <a:solidFill>
+            <a:srgbClr val="ECFCF3"/>
+          </a:solidFill>
+          <a:ln w="12700">
+            <a:solidFill>
+              <a:srgbClr val="15803D"/>
+            </a:solidFill>
+          </a:ln>
+          <a:effectLst/>
+        </p:spPr>
+        <p:style>
+          <a:lnRef idx="1">
+            <a:schemeClr val="accent1"/>
+          </a:lnRef>
+          <a:fillRef idx="3">
+            <a:schemeClr val="accent1"/>
+          </a:fillRef>
+          <a:effectRef idx="2">
+            <a:schemeClr val="accent1"/>
+          </a:effectRef>
+          <a:fontRef idx="minor">
+            <a:schemeClr val="lt1"/>
+          </a:fontRef>
+        </p:style>
+        <p:txBody>
+          <a:bodyPr rtlCol="0" anchor="ctr" wrap="square" lIns="128016" rIns="54864" tIns="0" bIns="0"/>
+          <a:lstStyle/>
+          <a:p>
+            <a:pPr algn="l">
+              <a:spcAft>
+                <a:spcPts val="0"/>
+              </a:spcAft>
+            </a:pPr>
+            <a:r>
+              <a:rPr sz="1050" b="1">
+                <a:solidFill>
+                  <a:srgbClr val="1C1917"/>
+                </a:solidFill>
+                <a:latin typeface="Calibri"/>
+              </a:rPr>
+              <a:t>Reward eligibility → admin-reviewed claim</a:t>
+            </a:r>
+          </a:p>
+        </p:txBody>
+      </p:sp>
+      <p:sp>
+        <p:nvSpPr>
+          <p:cNvPr id="25" name="Oval 24"/>
+          <p:cNvSpPr/>
+          <p:nvPr/>
+        </p:nvSpPr>
+        <p:spPr>
+          <a:xfrm>
+            <a:off x="6309359" y="4553712"/>
+            <a:ext cx="310896" cy="310896"/>
+          </a:xfrm>
+          <a:prstGeom prst="ellipse">
+            <a:avLst/>
+          </a:prstGeom>
+          <a:solidFill>
+            <a:srgbClr val="C81E1E"/>
+          </a:solidFill>
+          <a:ln>
+            <a:noFill/>
+          </a:ln>
+          <a:effectLst/>
+        </p:spPr>
+        <p:style>
+          <a:lnRef idx="1">
+            <a:schemeClr val="accent1"/>
+          </a:lnRef>
+          <a:fillRef idx="3">
+            <a:schemeClr val="accent1"/>
+          </a:fillRef>
+          <a:effectRef idx="2">
+            <a:schemeClr val="accent1"/>
+          </a:effectRef>
+          <a:fontRef idx="minor">
+            <a:schemeClr val="lt1"/>
+          </a:fontRef>
+        </p:style>
+        <p:txBody>
+          <a:bodyPr rtlCol="0" anchor="ctr" wrap="square" lIns="54864" rIns="54864" tIns="36576" bIns="36576"/>
+          <a:lstStyle/>
+          <a:p>
+            <a:pPr algn="ctr">
+              <a:spcAft>
+                <a:spcPts val="0"/>
+              </a:spcAft>
+            </a:pPr>
+            <a:r>
+              <a:rPr sz="1100" b="1">
+                <a:solidFill>
+                  <a:srgbClr val="FFFFFF"/>
+                </a:solidFill>
+                <a:latin typeface="Calibri"/>
+              </a:rPr>
+              <a:t>5</a:t>
+            </a:r>
+          </a:p>
+        </p:txBody>
+      </p:sp>
+      <p:sp>
+        <p:nvSpPr>
+          <p:cNvPr id="26" name="TextBox 25"/>
+          <p:cNvSpPr txBox="1"/>
+          <p:nvPr/>
+        </p:nvSpPr>
+        <p:spPr>
+          <a:xfrm>
+            <a:off x="6583680" y="5148072"/>
+            <a:ext cx="4937760" cy="731520"/>
+          </a:xfrm>
+          <a:prstGeom prst="rect">
+            <a:avLst/>
+          </a:prstGeom>
+          <a:noFill/>
+        </p:spPr>
+        <p:txBody>
+          <a:bodyPr wrap="square" anchor="t" lIns="0" rIns="0" tIns="0" bIns="0">
+            <a:spAutoFit/>
+          </a:bodyPr>
+          <a:lstStyle/>
+          <a:p>
+            <a:pPr algn="l">
+              <a:spcAft>
+                <a:spcPts val="0"/>
+              </a:spcAft>
+            </a:pPr>
+            <a:r>
+              <a:rPr sz="1050" b="1">
+                <a:solidFill>
+                  <a:srgbClr val="C81E1E"/>
+                </a:solidFill>
+                <a:latin typeface="Calibri"/>
+              </a:rPr>
+              <a:t>Protections: </a:t>
+            </a:r>
+            <a:r>
+              <a:rPr sz="1050" b="0">
+                <a:solidFill>
+                  <a:srgbClr val="57534E"/>
+                </a:solidFill>
+                <a:latin typeface="Calibri"/>
+              </a:rPr>
+              <a:t>8 tracked stages per referral · unique per-user codes · self-referral &amp; duplicate-device fraud checks · campaigns need admin approval notes</a:t>
+            </a:r>
+          </a:p>
+        </p:txBody>
+      </p:sp>
+      <p:sp>
+        <p:nvSpPr>
+          <p:cNvPr id="27" name="Rounded Rectangle 26"/>
+          <p:cNvSpPr/>
+          <p:nvPr/>
+        </p:nvSpPr>
+        <p:spPr>
+          <a:xfrm>
+            <a:off x="402336" y="6035040"/>
+            <a:ext cx="11384280" cy="457200"/>
+          </a:xfrm>
+          <a:prstGeom prst="roundRect">
+            <a:avLst/>
+          </a:prstGeom>
+          <a:solidFill>
+            <a:srgbClr val="FEF3C7"/>
+          </a:solidFill>
+          <a:ln w="12700">
+            <a:solidFill>
+              <a:srgbClr val="B45309"/>
+            </a:solidFill>
+          </a:ln>
+          <a:effectLst/>
+        </p:spPr>
+        <p:style>
+          <a:lnRef idx="1">
+            <a:schemeClr val="accent1"/>
+          </a:lnRef>
+          <a:fillRef idx="3">
+            <a:schemeClr val="accent1"/>
+          </a:fillRef>
+          <a:effectRef idx="2">
+            <a:schemeClr val="accent1"/>
+          </a:effectRef>
+          <a:fontRef idx="minor">
+            <a:schemeClr val="lt1"/>
+          </a:fontRef>
+        </p:style>
+        <p:txBody>
+          <a:bodyPr rtlCol="0" anchor="ctr" wrap="square" lIns="54864" rIns="54864" tIns="36576" bIns="36576"/>
+          <a:lstStyle/>
+          <a:p>
+            <a:pPr algn="ctr">
+              <a:spcAft>
+                <a:spcPts val="0"/>
+              </a:spcAft>
+            </a:pPr>
+            <a:r>
+              <a:rPr sz="1150" b="1">
+                <a:solidFill>
+                  <a:srgbClr val="B45309"/>
+                </a:solidFill>
+                <a:latin typeface="Calibri"/>
+              </a:rPr>
+              <a:t>Ethics by design: </a:t>
+            </a:r>
+            <a:r>
+              <a:rPr sz="1150" b="0">
+                <a:solidFill>
+                  <a:srgbClr val="1C1917"/>
+                </a:solidFill>
+                <a:latin typeface="Calibri"/>
+              </a:rPr>
+              <a:t>no cash equivalents, nothing tied to the act of donating, and every incentive is disclosed in the UI.</a:t>
+            </a:r>
+          </a:p>
+        </p:txBody>
+      </p:sp>
+    </p:spTree>
+  </p:cSld>
+  <p:clrMapOvr>
+    <a:masterClrMapping/>
+  </p:clrMapOvr>
+</p:sld>
+</file>
+
+<file path=ppt/slides/slide7.xml><?xml version="1.0" encoding="utf-8"?>
+<p:sld xmlns:a="http://schemas.openxmlformats.org/drawingml/2006/main" xmlns:p="http://schemas.openxmlformats.org/presentationml/2006/main" xmlns:r="http://schemas.openxmlformats.org/officeDocument/2006/relationships">
+  <p:cSld>
+    <p:spTree>
+      <p:nvGrpSpPr>
+        <p:cNvPr id="1" name=""/>
+        <p:cNvGrpSpPr/>
+        <p:nvPr/>
+      </p:nvGrpSpPr>
+      <p:grpSpPr/>
+      <p:sp>
+        <p:nvSpPr>
+          <p:cNvPr id="2" name="TextBox 1"/>
+          <p:cNvSpPr txBox="1"/>
+          <p:nvPr/>
+        </p:nvSpPr>
+        <p:spPr>
+          <a:xfrm>
+            <a:off x="402336" y="292608"/>
+            <a:ext cx="11384280" cy="320040"/>
+          </a:xfrm>
+          <a:prstGeom prst="rect">
+            <a:avLst/>
+          </a:prstGeom>
+          <a:noFill/>
+        </p:spPr>
+        <p:txBody>
+          <a:bodyPr wrap="square" anchor="t" lIns="0" rIns="0" tIns="0" bIns="0">
+            <a:spAutoFit/>
+          </a:bodyPr>
+          <a:lstStyle/>
+          <a:p>
+            <a:pPr algn="l">
+              <a:spcAft>
+                <a:spcPts val="0"/>
+              </a:spcAft>
+            </a:pPr>
+            <a:r>
+              <a:rPr sz="1200" b="1">
+                <a:solidFill>
+                  <a:srgbClr val="C81E1E"/>
+                </a:solidFill>
+                <a:latin typeface="Calibri"/>
+              </a:rPr>
+              <a:t>UNDER THE HOOD</a:t>
+            </a:r>
+          </a:p>
+        </p:txBody>
+      </p:sp>
+      <p:sp>
+        <p:nvSpPr>
+          <p:cNvPr id="3" name="TextBox 2"/>
+          <p:cNvSpPr txBox="1"/>
+          <p:nvPr/>
+        </p:nvSpPr>
+        <p:spPr>
+          <a:xfrm>
+            <a:off x="402336" y="566928"/>
+            <a:ext cx="11384280" cy="566928"/>
+          </a:xfrm>
+          <a:prstGeom prst="rect">
+            <a:avLst/>
+          </a:prstGeom>
+          <a:noFill/>
+        </p:spPr>
+        <p:txBody>
+          <a:bodyPr wrap="square" anchor="t" lIns="0" rIns="0" tIns="0" bIns="0">
+            <a:spAutoFit/>
+          </a:bodyPr>
+          <a:lstStyle/>
+          <a:p>
+            <a:pPr algn="l">
+              <a:spcAft>
+                <a:spcPts val="0"/>
+              </a:spcAft>
+            </a:pPr>
+            <a:r>
+              <a:rPr sz="2800" b="1">
+                <a:solidFill>
+                  <a:srgbClr val="1C1917"/>
+                </a:solidFill>
+                <a:latin typeface="Calibri"/>
+              </a:rPr>
+              <a:t>Architecture, quality and how to try it live</a:t>
+            </a:r>
+          </a:p>
+        </p:txBody>
+      </p:sp>
+      <p:sp>
+        <p:nvSpPr>
+          <p:cNvPr id="4" name="Rectangle 3"/>
+          <p:cNvSpPr/>
+          <p:nvPr/>
+        </p:nvSpPr>
+        <p:spPr>
+          <a:xfrm>
+            <a:off x="429768" y="1207008"/>
+            <a:ext cx="1234440" cy="41148"/>
+          </a:xfrm>
+          <a:prstGeom prst="rect">
+            <a:avLst/>
+          </a:prstGeom>
+          <a:solidFill>
+            <a:srgbClr val="C81E1E"/>
+          </a:solidFill>
+          <a:ln>
+            <a:noFill/>
+          </a:ln>
+          <a:effectLst/>
+        </p:spPr>
+        <p:style>
+          <a:lnRef idx="1">
+            <a:schemeClr val="accent1"/>
+          </a:lnRef>
+          <a:fillRef idx="3">
+            <a:schemeClr val="accent1"/>
+          </a:fillRef>
+          <a:effectRef idx="2">
+            <a:schemeClr val="accent1"/>
+          </a:effectRef>
+          <a:fontRef idx="minor">
+            <a:schemeClr val="lt1"/>
+          </a:fontRef>
+        </p:style>
+        <p:txBody>
+          <a:bodyPr rtlCol="0" anchor="ctr"/>
+          <a:lstStyle/>
+          <a:p>
+            <a:pPr algn="ctr"/>
+          </a:p>
+        </p:txBody>
+      </p:sp>
+      <p:sp>
+        <p:nvSpPr>
+          <p:cNvPr id="5" name="TextBox 4"/>
+          <p:cNvSpPr txBox="1"/>
+          <p:nvPr/>
+        </p:nvSpPr>
+        <p:spPr>
+          <a:xfrm>
+            <a:off x="402336" y="6473952"/>
+            <a:ext cx="8229600" cy="274320"/>
+          </a:xfrm>
+          <a:prstGeom prst="rect">
+            <a:avLst/>
+          </a:prstGeom>
+          <a:noFill/>
+        </p:spPr>
+        <p:txBody>
+          <a:bodyPr wrap="square" anchor="t" lIns="0" rIns="0" tIns="0" bIns="0">
+            <a:spAutoFit/>
+          </a:bodyPr>
+          <a:lstStyle/>
+          <a:p>
+            <a:pPr algn="l">
+              <a:spcAft>
+                <a:spcPts val="0"/>
+              </a:spcAft>
+            </a:pPr>
+            <a:r>
+              <a:rPr sz="900" b="0">
+                <a:solidFill>
+                  <a:srgbClr val="57534E"/>
+                </a:solidFill>
+                <a:latin typeface="Calibri"/>
+              </a:rPr>
+              <a:t>BloodBridge - AI-assisted blood donor discovery  ·  LIVE: https://bloodbridge-app.riteshnethi-art.workers.dev</a:t>
+            </a:r>
+          </a:p>
+        </p:txBody>
+      </p:sp>
+      <p:sp>
+        <p:nvSpPr>
+          <p:cNvPr id="6" name="TextBox 5"/>
+          <p:cNvSpPr txBox="1"/>
+          <p:nvPr/>
+        </p:nvSpPr>
+        <p:spPr>
+          <a:xfrm>
+            <a:off x="10972800" y="6473952"/>
+            <a:ext cx="822960" cy="274320"/>
+          </a:xfrm>
+          <a:prstGeom prst="rect">
+            <a:avLst/>
+          </a:prstGeom>
+          <a:noFill/>
+        </p:spPr>
+        <p:txBody>
+          <a:bodyPr wrap="square" anchor="t" lIns="0" rIns="0" tIns="0" bIns="0">
+            <a:spAutoFit/>
+          </a:bodyPr>
+          <a:lstStyle/>
+          <a:p>
+            <a:pPr algn="r">
+              <a:spcAft>
+                <a:spcPts val="0"/>
+              </a:spcAft>
+            </a:pPr>
+            <a:r>
+              <a:rPr sz="900" b="0">
+                <a:solidFill>
+                  <a:srgbClr val="57534E"/>
+                </a:solidFill>
+                <a:latin typeface="Calibri"/>
+              </a:rPr>
+              <a:t>7 / 7</a:t>
+            </a:r>
+          </a:p>
+        </p:txBody>
+      </p:sp>
+      <p:sp>
+        <p:nvSpPr>
+          <p:cNvPr id="7" name="Rounded Rectangle 6"/>
+          <p:cNvSpPr/>
+          <p:nvPr/>
+        </p:nvSpPr>
+        <p:spPr>
+          <a:xfrm>
+            <a:off x="591159" y="1627632"/>
+            <a:ext cx="3291840" cy="1481328"/>
           </a:xfrm>
           <a:prstGeom prst="roundRect">
             <a:avLst>
@@ -8808,7 +8947,7 @@
                 </a:solidFill>
                 <a:latin typeface="Calibri"/>
               </a:rPr>
-              <a:t>Data</a:t>
+              <a:t>Frontend</a:t>
             </a:r>
           </a:p>
           <a:p>
@@ -8824,21 +8963,21 @@
                 </a:solidFill>
                 <a:latin typeface="Calibri"/>
               </a:rPr>
-              <a:t>SQLAlchemy ORM · 15 models
-SQLite now, PostgreSQL-ready by config</a:t>
-            </a:r>
-          </a:p>
-        </p:txBody>
-      </p:sp>
-      <p:sp>
-        <p:nvSpPr>
-          <p:cNvPr id="14" name="Oval 13"/>
+              <a:t>React 18 · TypeScript · Vite · Tailwind
+12 pages, protected routes, notification bell</a:t>
+            </a:r>
+          </a:p>
+        </p:txBody>
+      </p:sp>
+      <p:sp>
+        <p:nvSpPr>
+          <p:cNvPr id="8" name="Oval 7"/>
           <p:cNvSpPr/>
           <p:nvPr/>
         </p:nvSpPr>
         <p:spPr>
           <a:xfrm>
-            <a:off x="8189823" y="1399031"/>
+            <a:off x="472287" y="1508760"/>
             <a:ext cx="329184" cy="329184"/>
           </a:xfrm>
           <a:prstGeom prst="ellipse">
@@ -8882,103 +9021,26 @@
                 </a:solidFill>
                 <a:latin typeface="Calibri"/>
               </a:rPr>
-              <a:t>3</a:t>
-            </a:r>
-          </a:p>
-        </p:txBody>
-      </p:sp>
-      <p:sp>
-        <p:nvSpPr>
-          <p:cNvPr id="15" name="Rounded Rectangle 14"/>
-          <p:cNvSpPr/>
-          <p:nvPr/>
-        </p:nvSpPr>
-        <p:spPr>
-          <a:xfrm>
-            <a:off x="4587087" y="2962656"/>
-            <a:ext cx="3017520" cy="566928"/>
-          </a:xfrm>
-          <a:prstGeom prst="roundRect">
-            <a:avLst>
-              <a:gd name="adj" fmla="val 15000"/>
-            </a:avLst>
-          </a:prstGeom>
-          <a:solidFill>
-            <a:srgbClr val="FFFFFF"/>
-          </a:solidFill>
-          <a:ln w="12700">
-            <a:solidFill>
-              <a:srgbClr val="57534E"/>
-            </a:solidFill>
-          </a:ln>
-          <a:effectLst/>
-        </p:spPr>
-        <p:style>
-          <a:lnRef idx="1">
-            <a:schemeClr val="accent1"/>
-          </a:lnRef>
-          <a:fillRef idx="3">
-            <a:schemeClr val="accent1"/>
-          </a:fillRef>
-          <a:effectRef idx="2">
-            <a:schemeClr val="accent1"/>
-          </a:effectRef>
-          <a:fontRef idx="minor">
-            <a:schemeClr val="lt1"/>
-          </a:fontRef>
-        </p:style>
-        <p:txBody>
-          <a:bodyPr rtlCol="0" anchor="ctr" wrap="square" lIns="54864" rIns="54864" tIns="36576" bIns="36576"/>
-          <a:lstStyle/>
-          <a:p>
-            <a:pPr algn="ctr">
-              <a:spcAft>
-                <a:spcPts val="100"/>
-              </a:spcAft>
-            </a:pPr>
-            <a:r>
-              <a:rPr sz="1000" b="1">
-                <a:solidFill>
-                  <a:srgbClr val="57534E"/>
-                </a:solidFill>
-                <a:latin typeface="Calibri"/>
-              </a:rPr>
-              <a:t>Optional: Gemini extraction</a:t>
-            </a:r>
-          </a:p>
-          <a:p>
-            <a:pPr algn="ctr">
-              <a:spcAft>
-                <a:spcPts val="0"/>
-              </a:spcAft>
-            </a:pPr>
-            <a:r>
-              <a:rPr sz="850" b="0">
-                <a:solidFill>
-                  <a:srgbClr val="57534E"/>
-                </a:solidFill>
-                <a:latin typeface="Calibri"/>
-              </a:rPr>
-              <a:t>falls back to deterministic parser</a:t>
+              <a:t>1</a:t>
             </a:r>
           </a:p>
         </p:txBody>
       </p:sp>
       <p:cxnSp>
         <p:nvCxnSpPr>
-          <p:cNvPr id="16" name="Connector 15"/>
+          <p:cNvPr id="9" name="Connector 8"/>
           <p:cNvCxnSpPr/>
           <p:nvPr/>
         </p:nvCxnSpPr>
         <p:spPr>
-          <a:xfrm flipV="1">
-            <a:off x="6095847" y="2770632"/>
-            <a:ext cx="0" cy="173736"/>
+          <a:xfrm>
+            <a:off x="3937863" y="2368296"/>
+            <a:ext cx="457200" cy="0"/>
           </a:xfrm>
           <a:prstGeom prst="line">
             <a:avLst/>
           </a:prstGeom>
-          <a:ln w="15875">
+          <a:ln w="22225">
             <a:solidFill>
               <a:srgbClr val="57534E"/>
             </a:solidFill>
@@ -9003,95 +9065,18 @@
       </p:cxnSp>
       <p:sp>
         <p:nvSpPr>
-          <p:cNvPr id="17" name="Rounded Rectangle 16"/>
+          <p:cNvPr id="10" name="Rounded Rectangle 9"/>
           <p:cNvSpPr/>
           <p:nvPr/>
         </p:nvSpPr>
         <p:spPr>
           <a:xfrm>
-            <a:off x="4587087" y="3621024"/>
-            <a:ext cx="3017520" cy="566928"/>
+            <a:off x="4449927" y="1627632"/>
+            <a:ext cx="3291840" cy="1481328"/>
           </a:xfrm>
           <a:prstGeom prst="roundRect">
             <a:avLst>
-              <a:gd name="adj" fmla="val 15000"/>
-            </a:avLst>
-          </a:prstGeom>
-          <a:solidFill>
-            <a:srgbClr val="FFFFFF"/>
-          </a:solidFill>
-          <a:ln w="12700">
-            <a:solidFill>
-              <a:srgbClr val="57534E"/>
-            </a:solidFill>
-          </a:ln>
-          <a:effectLst/>
-        </p:spPr>
-        <p:style>
-          <a:lnRef idx="1">
-            <a:schemeClr val="accent1"/>
-          </a:lnRef>
-          <a:fillRef idx="3">
-            <a:schemeClr val="accent1"/>
-          </a:fillRef>
-          <a:effectRef idx="2">
-            <a:schemeClr val="accent1"/>
-          </a:effectRef>
-          <a:fontRef idx="minor">
-            <a:schemeClr val="lt1"/>
-          </a:fontRef>
-        </p:style>
-        <p:txBody>
-          <a:bodyPr rtlCol="0" anchor="ctr" wrap="square" lIns="54864" rIns="54864" tIns="36576" bIns="36576"/>
-          <a:lstStyle/>
-          <a:p>
-            <a:pPr algn="ctr">
-              <a:spcAft>
-                <a:spcPts val="100"/>
-              </a:spcAft>
-            </a:pPr>
-            <a:r>
-              <a:rPr sz="1000" b="1">
-                <a:solidFill>
-                  <a:srgbClr val="57534E"/>
-                </a:solidFill>
-                <a:latin typeface="Calibri"/>
-              </a:rPr>
-              <a:t>Optional: WhatsApp Cloud API</a:t>
-            </a:r>
-          </a:p>
-          <a:p>
-            <a:pPr algn="ctr">
-              <a:spcAft>
-                <a:spcPts val="0"/>
-              </a:spcAft>
-            </a:pPr>
-            <a:r>
-              <a:rPr sz="850" b="0">
-                <a:solidFill>
-                  <a:srgbClr val="57534E"/>
-                </a:solidFill>
-                <a:latin typeface="Calibri"/>
-              </a:rPr>
-              <a:t>webhook verify · dedupe · demo labeling</a:t>
-            </a:r>
-          </a:p>
-        </p:txBody>
-      </p:sp>
-      <p:sp>
-        <p:nvSpPr>
-          <p:cNvPr id="18" name="Rounded Rectangle 17"/>
-          <p:cNvSpPr/>
-          <p:nvPr/>
-        </p:nvSpPr>
-        <p:spPr>
-          <a:xfrm>
-            <a:off x="402336" y="4315968"/>
-            <a:ext cx="6675120" cy="1874519"/>
-          </a:xfrm>
-          <a:prstGeom prst="roundRect">
-            <a:avLst>
-              <a:gd name="adj" fmla="val 6000"/>
+              <a:gd name="adj" fmla="val 10000"/>
             </a:avLst>
           </a:prstGeom>
           <a:solidFill>
@@ -9119,6 +9104,313 @@
           </a:fontRef>
         </p:style>
         <p:txBody>
+          <a:bodyPr rtlCol="0" anchor="ctr" wrap="square" lIns="73152" rIns="73152" tIns="18288" bIns="18288"/>
+          <a:lstStyle/>
+          <a:p>
+            <a:pPr algn="ctr">
+              <a:spcAft>
+                <a:spcPts val="300"/>
+              </a:spcAft>
+            </a:pPr>
+            <a:r>
+              <a:rPr sz="1250" b="1">
+                <a:solidFill>
+                  <a:srgbClr val="1C1917"/>
+                </a:solidFill>
+                <a:latin typeface="Calibri"/>
+              </a:rPr>
+              <a:t>API</a:t>
+            </a:r>
+          </a:p>
+          <a:p>
+            <a:pPr algn="ctr">
+              <a:spcAft>
+                <a:spcPts val="0"/>
+              </a:spcAft>
+            </a:pPr>
+            <a:r>
+              <a:rPr sz="950" b="0">
+                <a:solidFill>
+                  <a:srgbClr val="57534E"/>
+                </a:solidFill>
+                <a:latin typeface="Calibri"/>
+              </a:rPr>
+              <a:t>FastAPI · Pydantic schemas
+9 routers, role-based auth (PBKDF2 + HMAC tokens)</a:t>
+            </a:r>
+          </a:p>
+        </p:txBody>
+      </p:sp>
+      <p:sp>
+        <p:nvSpPr>
+          <p:cNvPr id="11" name="Oval 10"/>
+          <p:cNvSpPr/>
+          <p:nvPr/>
+        </p:nvSpPr>
+        <p:spPr>
+          <a:xfrm>
+            <a:off x="4331055" y="1508760"/>
+            <a:ext cx="329184" cy="329184"/>
+          </a:xfrm>
+          <a:prstGeom prst="ellipse">
+            <a:avLst/>
+          </a:prstGeom>
+          <a:solidFill>
+            <a:srgbClr val="C81E1E"/>
+          </a:solidFill>
+          <a:ln>
+            <a:noFill/>
+          </a:ln>
+          <a:effectLst/>
+        </p:spPr>
+        <p:style>
+          <a:lnRef idx="1">
+            <a:schemeClr val="accent1"/>
+          </a:lnRef>
+          <a:fillRef idx="3">
+            <a:schemeClr val="accent1"/>
+          </a:fillRef>
+          <a:effectRef idx="2">
+            <a:schemeClr val="accent1"/>
+          </a:effectRef>
+          <a:fontRef idx="minor">
+            <a:schemeClr val="lt1"/>
+          </a:fontRef>
+        </p:style>
+        <p:txBody>
+          <a:bodyPr rtlCol="0" anchor="ctr" wrap="square" lIns="54864" rIns="54864" tIns="36576" bIns="36576"/>
+          <a:lstStyle/>
+          <a:p>
+            <a:pPr algn="ctr">
+              <a:spcAft>
+                <a:spcPts val="0"/>
+              </a:spcAft>
+            </a:pPr>
+            <a:r>
+              <a:rPr sz="1300" b="1">
+                <a:solidFill>
+                  <a:srgbClr val="FFFFFF"/>
+                </a:solidFill>
+                <a:latin typeface="Calibri"/>
+              </a:rPr>
+              <a:t>2</a:t>
+            </a:r>
+          </a:p>
+        </p:txBody>
+      </p:sp>
+      <p:cxnSp>
+        <p:nvCxnSpPr>
+          <p:cNvPr id="12" name="Connector 11"/>
+          <p:cNvCxnSpPr/>
+          <p:nvPr/>
+        </p:nvCxnSpPr>
+        <p:spPr>
+          <a:xfrm>
+            <a:off x="7796631" y="2368296"/>
+            <a:ext cx="457200" cy="0"/>
+          </a:xfrm>
+          <a:prstGeom prst="line">
+            <a:avLst/>
+          </a:prstGeom>
+          <a:ln w="22225">
+            <a:solidFill>
+              <a:srgbClr val="57534E"/>
+            </a:solidFill>
+            <a:tailEnd type="triangle" w="med" len="med"/>
+          </a:ln>
+          <a:effectLst/>
+        </p:spPr>
+        <p:style>
+          <a:lnRef idx="2">
+            <a:schemeClr val="accent1"/>
+          </a:lnRef>
+          <a:fillRef idx="0">
+            <a:schemeClr val="accent1"/>
+          </a:fillRef>
+          <a:effectRef idx="1">
+            <a:schemeClr val="accent1"/>
+          </a:effectRef>
+          <a:fontRef idx="minor">
+            <a:schemeClr val="tx1"/>
+          </a:fontRef>
+        </p:style>
+      </p:cxnSp>
+      <p:sp>
+        <p:nvSpPr>
+          <p:cNvPr id="13" name="Rounded Rectangle 12"/>
+          <p:cNvSpPr/>
+          <p:nvPr/>
+        </p:nvSpPr>
+        <p:spPr>
+          <a:xfrm>
+            <a:off x="8308695" y="1627632"/>
+            <a:ext cx="3291840" cy="1481328"/>
+          </a:xfrm>
+          <a:prstGeom prst="roundRect">
+            <a:avLst>
+              <a:gd name="adj" fmla="val 10000"/>
+            </a:avLst>
+          </a:prstGeom>
+          <a:solidFill>
+            <a:srgbClr val="FFFFFF"/>
+          </a:solidFill>
+          <a:ln w="15875">
+            <a:solidFill>
+              <a:srgbClr val="E7E5E4"/>
+            </a:solidFill>
+          </a:ln>
+          <a:effectLst/>
+        </p:spPr>
+        <p:style>
+          <a:lnRef idx="1">
+            <a:schemeClr val="accent1"/>
+          </a:lnRef>
+          <a:fillRef idx="3">
+            <a:schemeClr val="accent1"/>
+          </a:fillRef>
+          <a:effectRef idx="2">
+            <a:schemeClr val="accent1"/>
+          </a:effectRef>
+          <a:fontRef idx="minor">
+            <a:schemeClr val="lt1"/>
+          </a:fontRef>
+        </p:style>
+        <p:txBody>
+          <a:bodyPr rtlCol="0" anchor="ctr" wrap="square" lIns="73152" rIns="73152" tIns="18288" bIns="18288"/>
+          <a:lstStyle/>
+          <a:p>
+            <a:pPr algn="ctr">
+              <a:spcAft>
+                <a:spcPts val="300"/>
+              </a:spcAft>
+            </a:pPr>
+            <a:r>
+              <a:rPr sz="1250" b="1">
+                <a:solidFill>
+                  <a:srgbClr val="1C1917"/>
+                </a:solidFill>
+                <a:latin typeface="Calibri"/>
+              </a:rPr>
+              <a:t>Data</a:t>
+            </a:r>
+          </a:p>
+          <a:p>
+            <a:pPr algn="ctr">
+              <a:spcAft>
+                <a:spcPts val="0"/>
+              </a:spcAft>
+            </a:pPr>
+            <a:r>
+              <a:rPr sz="950" b="0">
+                <a:solidFill>
+                  <a:srgbClr val="57534E"/>
+                </a:solidFill>
+                <a:latin typeface="Calibri"/>
+              </a:rPr>
+              <a:t>SQLAlchemy ORM · 15 models
+SQLite now, PostgreSQL-ready by config</a:t>
+            </a:r>
+          </a:p>
+        </p:txBody>
+      </p:sp>
+      <p:sp>
+        <p:nvSpPr>
+          <p:cNvPr id="14" name="Oval 13"/>
+          <p:cNvSpPr/>
+          <p:nvPr/>
+        </p:nvSpPr>
+        <p:spPr>
+          <a:xfrm>
+            <a:off x="8189823" y="1508760"/>
+            <a:ext cx="329184" cy="329184"/>
+          </a:xfrm>
+          <a:prstGeom prst="ellipse">
+            <a:avLst/>
+          </a:prstGeom>
+          <a:solidFill>
+            <a:srgbClr val="C81E1E"/>
+          </a:solidFill>
+          <a:ln>
+            <a:noFill/>
+          </a:ln>
+          <a:effectLst/>
+        </p:spPr>
+        <p:style>
+          <a:lnRef idx="1">
+            <a:schemeClr val="accent1"/>
+          </a:lnRef>
+          <a:fillRef idx="3">
+            <a:schemeClr val="accent1"/>
+          </a:fillRef>
+          <a:effectRef idx="2">
+            <a:schemeClr val="accent1"/>
+          </a:effectRef>
+          <a:fontRef idx="minor">
+            <a:schemeClr val="lt1"/>
+          </a:fontRef>
+        </p:style>
+        <p:txBody>
+          <a:bodyPr rtlCol="0" anchor="ctr" wrap="square" lIns="54864" rIns="54864" tIns="36576" bIns="36576"/>
+          <a:lstStyle/>
+          <a:p>
+            <a:pPr algn="ctr">
+              <a:spcAft>
+                <a:spcPts val="0"/>
+              </a:spcAft>
+            </a:pPr>
+            <a:r>
+              <a:rPr sz="1300" b="1">
+                <a:solidFill>
+                  <a:srgbClr val="FFFFFF"/>
+                </a:solidFill>
+                <a:latin typeface="Calibri"/>
+              </a:rPr>
+              <a:t>3</a:t>
+            </a:r>
+          </a:p>
+        </p:txBody>
+      </p:sp>
+      <p:sp>
+        <p:nvSpPr>
+          <p:cNvPr id="15" name="Rounded Rectangle 14"/>
+          <p:cNvSpPr/>
+          <p:nvPr/>
+        </p:nvSpPr>
+        <p:spPr>
+          <a:xfrm>
+            <a:off x="402336" y="3977639"/>
+            <a:ext cx="6675120" cy="2103120"/>
+          </a:xfrm>
+          <a:prstGeom prst="roundRect">
+            <a:avLst>
+              <a:gd name="adj" fmla="val 6000"/>
+            </a:avLst>
+          </a:prstGeom>
+          <a:solidFill>
+            <a:srgbClr val="FFFFFF"/>
+          </a:solidFill>
+          <a:ln w="15875">
+            <a:solidFill>
+              <a:srgbClr val="E7E5E4"/>
+            </a:solidFill>
+          </a:ln>
+          <a:effectLst/>
+        </p:spPr>
+        <p:style>
+          <a:lnRef idx="1">
+            <a:schemeClr val="accent1"/>
+          </a:lnRef>
+          <a:fillRef idx="3">
+            <a:schemeClr val="accent1"/>
+          </a:fillRef>
+          <a:effectRef idx="2">
+            <a:schemeClr val="accent1"/>
+          </a:effectRef>
+          <a:fontRef idx="minor">
+            <a:schemeClr val="lt1"/>
+          </a:fontRef>
+        </p:style>
+        <p:txBody>
           <a:bodyPr rtlCol="0" anchor="ctr"/>
           <a:lstStyle/>
           <a:p>
@@ -9128,13 +9420,13 @@
       </p:sp>
       <p:sp>
         <p:nvSpPr>
-          <p:cNvPr id="19" name="TextBox 18"/>
+          <p:cNvPr id="16" name="TextBox 15"/>
           <p:cNvSpPr txBox="1"/>
           <p:nvPr/>
         </p:nvSpPr>
         <p:spPr>
           <a:xfrm>
-            <a:off x="640080" y="4407407"/>
+            <a:off x="640080" y="4087368"/>
             <a:ext cx="6217920" cy="320040"/>
           </a:xfrm>
           <a:prstGeom prst="rect">
@@ -9167,14 +9459,14 @@
       </p:sp>
       <p:sp>
         <p:nvSpPr>
-          <p:cNvPr id="20" name="TextBox 19"/>
+          <p:cNvPr id="17" name="TextBox 16"/>
           <p:cNvSpPr txBox="1"/>
           <p:nvPr/>
         </p:nvSpPr>
         <p:spPr>
           <a:xfrm>
-            <a:off x="640080" y="4736592"/>
-            <a:ext cx="6309360" cy="1371600"/>
+            <a:off x="640080" y="4453127"/>
+            <a:ext cx="6309360" cy="1554480"/>
           </a:xfrm>
           <a:prstGeom prst="rect">
             <a:avLst/>
@@ -9189,7 +9481,7 @@
           <a:p>
             <a:pPr algn="l">
               <a:spcAft>
-                <a:spcPts val="500"/>
+                <a:spcPts val="600"/>
               </a:spcAft>
             </a:pPr>
             <a:r>
@@ -9208,13 +9500,13 @@
                 </a:solidFill>
                 <a:latin typeface="Calibri"/>
               </a:rPr>
-              <a:t>63 backend tests + 10 frontend tests, all green</a:t>
+              <a:t>73 automated tests, all green, plus a live end-to-end browser run</a:t>
             </a:r>
           </a:p>
           <a:p>
             <a:pPr algn="l">
               <a:spcAft>
-                <a:spcPts val="500"/>
+                <a:spcPts val="600"/>
               </a:spcAft>
             </a:pPr>
             <a:r>
@@ -9239,7 +9531,7 @@
           <a:p>
             <a:pPr algn="l">
               <a:spcAft>
-                <a:spcPts val="500"/>
+                <a:spcPts val="600"/>
               </a:spcAft>
             </a:pPr>
             <a:r>
@@ -9264,7 +9556,7 @@
           <a:p>
             <a:pPr algn="l">
               <a:spcAft>
-                <a:spcPts val="500"/>
+                <a:spcPts val="600"/>
               </a:spcAft>
             </a:pPr>
             <a:r>
@@ -9290,14 +9582,14 @@
       </p:sp>
       <p:sp>
         <p:nvSpPr>
-          <p:cNvPr id="21" name="Rounded Rectangle 20"/>
+          <p:cNvPr id="18" name="Rounded Rectangle 17"/>
           <p:cNvSpPr/>
           <p:nvPr/>
         </p:nvSpPr>
         <p:spPr>
           <a:xfrm>
-            <a:off x="7315200" y="4315968"/>
-            <a:ext cx="4471416" cy="1874519"/>
+            <a:off x="7315200" y="3977639"/>
+            <a:ext cx="4471416" cy="2103120"/>
           </a:xfrm>
           <a:prstGeom prst="roundRect">
             <a:avLst>
@@ -9338,14 +9630,14 @@
       </p:sp>
       <p:sp>
         <p:nvSpPr>
-          <p:cNvPr id="22" name="TextBox 21"/>
+          <p:cNvPr id="19" name="TextBox 18"/>
           <p:cNvSpPr txBox="1"/>
           <p:nvPr/>
         </p:nvSpPr>
         <p:spPr>
           <a:xfrm>
-            <a:off x="7543800" y="4407407"/>
-            <a:ext cx="4023360" cy="320040"/>
+            <a:off x="7543800" y="4087368"/>
+            <a:ext cx="3291840" cy="320040"/>
           </a:xfrm>
           <a:prstGeom prst="rect">
             <a:avLst/>
@@ -9370,21 +9662,21 @@
                 </a:solidFill>
                 <a:latin typeface="Calibri"/>
               </a:rPr>
-              <a:t>TRY THE DEMO</a:t>
-            </a:r>
-          </a:p>
-        </p:txBody>
-      </p:sp>
-      <p:sp>
-        <p:nvSpPr>
-          <p:cNvPr id="23" name="TextBox 22"/>
+              <a:t>SCAN - IT IS LIVE NOW</a:t>
+            </a:r>
+          </a:p>
+        </p:txBody>
+      </p:sp>
+      <p:sp>
+        <p:nvSpPr>
+          <p:cNvPr id="20" name="TextBox 19"/>
           <p:cNvSpPr txBox="1"/>
           <p:nvPr/>
         </p:nvSpPr>
         <p:spPr>
           <a:xfrm>
-            <a:off x="7543800" y="4754879"/>
-            <a:ext cx="4069080" cy="1371600"/>
+            <a:off x="7543800" y="4453127"/>
+            <a:ext cx="3063240" cy="1508760"/>
           </a:xfrm>
           <a:prstGeom prst="rect">
             <a:avLst/>
@@ -9399,69 +9691,141 @@
           <a:p>
             <a:pPr algn="l">
               <a:spcAft>
+                <a:spcPts val="200"/>
+              </a:spcAft>
+            </a:pPr>
+            <a:r>
+              <a:rPr sz="1250" b="1">
+                <a:solidFill>
+                  <a:srgbClr val="1C1917"/>
+                </a:solidFill>
+                <a:latin typeface="Calibri"/>
+              </a:rPr>
+              <a:t>bloodbridge-app.</a:t>
+            </a:r>
+          </a:p>
+          <a:p>
+            <a:pPr algn="l">
+              <a:spcAft>
+                <a:spcPts val="800"/>
+              </a:spcAft>
+            </a:pPr>
+            <a:r>
+              <a:rPr sz="1250" b="1">
+                <a:solidFill>
+                  <a:srgbClr val="1C1917"/>
+                </a:solidFill>
+                <a:latin typeface="Calibri"/>
+              </a:rPr>
+              <a:t>riteshnethi-art.workers.dev</a:t>
+            </a:r>
+          </a:p>
+          <a:p>
+            <a:pPr algn="l">
+              <a:spcAft>
                 <a:spcPts val="600"/>
               </a:spcAft>
             </a:pPr>
             <a:r>
-              <a:rPr sz="1300" b="1">
+              <a:rPr sz="1000" b="0">
                 <a:solidFill>
                   <a:srgbClr val="1C1917"/>
                 </a:solidFill>
                 <a:latin typeface="Calibri"/>
               </a:rPr>
-              <a:t>http://localhost:5173</a:t>
+              <a:t>Free tier: Cloudflare Pages + Render</a:t>
             </a:r>
           </a:p>
           <a:p>
             <a:pPr algn="l">
               <a:spcAft>
-                <a:spcPts val="200"/>
-              </a:spcAft>
-            </a:pPr>
-            <a:r>
-              <a:rPr sz="1100" b="0">
-                <a:solidFill>
-                  <a:srgbClr val="1C1917"/>
-                </a:solidFill>
-                <a:latin typeface="Calibri"/>
-              </a:rPr>
-              <a:t>Admin:  admin@bloodbridge.demo</a:t>
-            </a:r>
-          </a:p>
-          <a:p>
-            <a:pPr algn="l">
-              <a:spcAft>
-                <a:spcPts val="800"/>
-              </a:spcAft>
-            </a:pPr>
-            <a:r>
-              <a:rPr sz="1100" b="0">
-                <a:solidFill>
-                  <a:srgbClr val="1C1917"/>
-                </a:solidFill>
-                <a:latin typeface="Calibri"/>
-              </a:rPr>
-              <a:t>Password:  demo123</a:t>
-            </a:r>
-          </a:p>
-          <a:p>
-            <a:pPr algn="l">
-              <a:spcAft>
                 <a:spcPts val="0"/>
               </a:spcAft>
             </a:pPr>
             <a:r>
-              <a:rPr sz="1000" b="0">
+              <a:rPr sz="950" b="0">
                 <a:solidFill>
                   <a:srgbClr val="57534E"/>
                 </a:solidFill>
                 <a:latin typeface="Calibri"/>
               </a:rPr>
-              <a:t>Seeded donors, offers, campaign &amp; live request BB-6D4006E5</a:t>
-            </a:r>
-          </a:p>
-        </p:txBody>
-      </p:sp>
+              <a:t>No login needed - demo data, clearly labeled</a:t>
+            </a:r>
+          </a:p>
+        </p:txBody>
+      </p:sp>
+      <p:sp>
+        <p:nvSpPr>
+          <p:cNvPr id="21" name="Rounded Rectangle 20"/>
+          <p:cNvSpPr/>
+          <p:nvPr/>
+        </p:nvSpPr>
+        <p:spPr>
+          <a:xfrm>
+            <a:off x="10104120" y="4142231"/>
+            <a:ext cx="1508760" cy="1508760"/>
+          </a:xfrm>
+          <a:prstGeom prst="roundRect">
+            <a:avLst>
+              <a:gd name="adj" fmla="val 6000"/>
+            </a:avLst>
+          </a:prstGeom>
+          <a:solidFill>
+            <a:srgbClr val="FFFFFF"/>
+          </a:solidFill>
+          <a:ln w="15875">
+            <a:solidFill>
+              <a:srgbClr val="E7E5E4"/>
+            </a:solidFill>
+          </a:ln>
+          <a:effectLst/>
+        </p:spPr>
+        <p:style>
+          <a:lnRef idx="1">
+            <a:schemeClr val="accent1"/>
+          </a:lnRef>
+          <a:fillRef idx="3">
+            <a:schemeClr val="accent1"/>
+          </a:fillRef>
+          <a:effectRef idx="2">
+            <a:schemeClr val="accent1"/>
+          </a:effectRef>
+          <a:fontRef idx="minor">
+            <a:schemeClr val="lt1"/>
+          </a:fontRef>
+        </p:style>
+        <p:txBody>
+          <a:bodyPr rtlCol="0" anchor="ctr"/>
+          <a:lstStyle/>
+          <a:p>
+            <a:pPr algn="ctr"/>
+          </a:p>
+        </p:txBody>
+      </p:sp>
+      <p:pic>
+        <p:nvPicPr>
+          <p:cNvPr id="22" name="Picture 21" descr="live_qr.png"/>
+          <p:cNvPicPr>
+            <a:picLocks noChangeAspect="1"/>
+          </p:cNvPicPr>
+          <p:nvPr/>
+        </p:nvPicPr>
+        <p:blipFill>
+          <a:blip r:embed="rId2"/>
+          <a:stretch>
+            <a:fillRect/>
+          </a:stretch>
+        </p:blipFill>
+        <p:spPr>
+          <a:xfrm>
+            <a:off x="10177272" y="4215383"/>
+            <a:ext cx="1362456" cy="1362456"/>
+          </a:xfrm>
+          <a:prstGeom prst="rect">
+            <a:avLst/>
+          </a:prstGeom>
+        </p:spPr>
+      </p:pic>
     </p:spTree>
   </p:cSld>
   <p:clrMapOvr>

</xml_diff>